<commit_message>
docs: mise à jour README, dashboard, présentation et schéma architecture
</commit_message>
<xml_diff>
--- a/P12_Gerez_un_projet_d_infrastructure_aymeric_bailleul/_orchestration/_docs/ABAI_02_presentation.pptx
+++ b/P12_Gerez_un_projet_d_infrastructure_aymeric_bailleul/_orchestration/_docs/ABAI_02_presentation.pptx
@@ -209,7 +209,7 @@
           <a:p>
             <a:fld id="{F16B76E8-7572-4EB5-8BC1-D8F277DA4831}" type="datetimeFigureOut">
               <a:rPr lang="fr-FR" smtClean="0"/>
-              <a:t>24/03/2026</a:t>
+              <a:t>25/03/2026</a:t>
             </a:fld>
             <a:endParaRPr lang="fr-FR"/>
           </a:p>
@@ -3614,7 +3614,7 @@
           <a:p>
             <a:fld id="{C372C99E-D69C-4ADF-8C8D-41420D3DDB02}" type="datetimeFigureOut">
               <a:rPr lang="fr-FR" smtClean="0"/>
-              <a:t>24/03/2026</a:t>
+              <a:t>25/03/2026</a:t>
             </a:fld>
             <a:endParaRPr lang="fr-FR"/>
           </a:p>
@@ -3812,7 +3812,7 @@
           <a:p>
             <a:fld id="{C372C99E-D69C-4ADF-8C8D-41420D3DDB02}" type="datetimeFigureOut">
               <a:rPr lang="fr-FR" smtClean="0"/>
-              <a:t>24/03/2026</a:t>
+              <a:t>25/03/2026</a:t>
             </a:fld>
             <a:endParaRPr lang="fr-FR"/>
           </a:p>
@@ -4020,7 +4020,7 @@
           <a:p>
             <a:fld id="{C372C99E-D69C-4ADF-8C8D-41420D3DDB02}" type="datetimeFigureOut">
               <a:rPr lang="fr-FR" smtClean="0"/>
-              <a:t>24/03/2026</a:t>
+              <a:t>25/03/2026</a:t>
             </a:fld>
             <a:endParaRPr lang="fr-FR"/>
           </a:p>
@@ -4218,7 +4218,7 @@
           <a:p>
             <a:fld id="{C372C99E-D69C-4ADF-8C8D-41420D3DDB02}" type="datetimeFigureOut">
               <a:rPr lang="fr-FR" smtClean="0"/>
-              <a:t>24/03/2026</a:t>
+              <a:t>25/03/2026</a:t>
             </a:fld>
             <a:endParaRPr lang="fr-FR"/>
           </a:p>
@@ -4493,7 +4493,7 @@
           <a:p>
             <a:fld id="{C372C99E-D69C-4ADF-8C8D-41420D3DDB02}" type="datetimeFigureOut">
               <a:rPr lang="fr-FR" smtClean="0"/>
-              <a:t>24/03/2026</a:t>
+              <a:t>25/03/2026</a:t>
             </a:fld>
             <a:endParaRPr lang="fr-FR"/>
           </a:p>
@@ -4758,7 +4758,7 @@
           <a:p>
             <a:fld id="{C372C99E-D69C-4ADF-8C8D-41420D3DDB02}" type="datetimeFigureOut">
               <a:rPr lang="fr-FR" smtClean="0"/>
-              <a:t>24/03/2026</a:t>
+              <a:t>25/03/2026</a:t>
             </a:fld>
             <a:endParaRPr lang="fr-FR"/>
           </a:p>
@@ -5170,7 +5170,7 @@
           <a:p>
             <a:fld id="{C372C99E-D69C-4ADF-8C8D-41420D3DDB02}" type="datetimeFigureOut">
               <a:rPr lang="fr-FR" smtClean="0"/>
-              <a:t>24/03/2026</a:t>
+              <a:t>25/03/2026</a:t>
             </a:fld>
             <a:endParaRPr lang="fr-FR"/>
           </a:p>
@@ -5311,7 +5311,7 @@
           <a:p>
             <a:fld id="{C372C99E-D69C-4ADF-8C8D-41420D3DDB02}" type="datetimeFigureOut">
               <a:rPr lang="fr-FR" smtClean="0"/>
-              <a:t>24/03/2026</a:t>
+              <a:t>25/03/2026</a:t>
             </a:fld>
             <a:endParaRPr lang="fr-FR"/>
           </a:p>
@@ -5424,7 +5424,7 @@
           <a:p>
             <a:fld id="{C372C99E-D69C-4ADF-8C8D-41420D3DDB02}" type="datetimeFigureOut">
               <a:rPr lang="fr-FR" smtClean="0"/>
-              <a:t>24/03/2026</a:t>
+              <a:t>25/03/2026</a:t>
             </a:fld>
             <a:endParaRPr lang="fr-FR"/>
           </a:p>
@@ -5735,7 +5735,7 @@
           <a:p>
             <a:fld id="{C372C99E-D69C-4ADF-8C8D-41420D3DDB02}" type="datetimeFigureOut">
               <a:rPr lang="fr-FR" smtClean="0"/>
-              <a:t>24/03/2026</a:t>
+              <a:t>25/03/2026</a:t>
             </a:fld>
             <a:endParaRPr lang="fr-FR"/>
           </a:p>
@@ -6023,7 +6023,7 @@
           <a:p>
             <a:fld id="{C372C99E-D69C-4ADF-8C8D-41420D3DDB02}" type="datetimeFigureOut">
               <a:rPr lang="fr-FR" smtClean="0"/>
-              <a:t>24/03/2026</a:t>
+              <a:t>25/03/2026</a:t>
             </a:fld>
             <a:endParaRPr lang="fr-FR"/>
           </a:p>
@@ -6273,7 +6273,7 @@
           <a:p>
             <a:fld id="{C372C99E-D69C-4ADF-8C8D-41420D3DDB02}" type="datetimeFigureOut">
               <a:rPr lang="fr-FR" smtClean="0"/>
-              <a:t>24/03/2026</a:t>
+              <a:t>25/03/2026</a:t>
             </a:fld>
             <a:endParaRPr lang="fr-FR"/>
           </a:p>
@@ -7044,7 +7044,7 @@
           <p:nvPr>
             <p:extLst>
               <p:ext uri="{D42A27DB-BD31-4B8C-83A1-F6EECF244321}">
-                <p14:modId xmlns:p14="http://schemas.microsoft.com/office/powerpoint/2010/main" val="2849900708"/>
+                <p14:modId xmlns:p14="http://schemas.microsoft.com/office/powerpoint/2010/main" val="1977063740"/>
               </p:ext>
             </p:extLst>
           </p:nvPr>
@@ -7624,7 +7624,7 @@
                         <a:t>, </a:t>
                       </a:r>
                       <a:r>
-                        <a:rPr dirty="0" err="1">
+                        <a:rPr lang="fr-FR" dirty="0">
                           <a:solidFill>
                             <a:schemeClr val="accent2">
                               <a:lumMod val="50000"/>
@@ -13477,27 +13477,6 @@
                   <a:srgbClr val="2C3E50"/>
                 </a:solidFill>
               </a:rPr>
-              <a:t>• 66 NaN (41 %) → Non déclaré</a:t>
-            </a:r>
-          </a:p>
-          <a:p>
-            <a:pPr marL="360363" algn="l">
-              <a:spcAft>
-                <a:spcPts val="600"/>
-              </a:spcAft>
-              <a:defRPr sz="1100" b="0">
-                <a:solidFill>
-                  <a:srgbClr val="2C3E50"/>
-                </a:solidFill>
-                <a:latin typeface="Calibri"/>
-              </a:defRPr>
-            </a:pPr>
-            <a:r>
-              <a:rPr lang="fr-FR" noProof="0" dirty="0">
-                <a:solidFill>
-                  <a:srgbClr val="2C3E50"/>
-                </a:solidFill>
-              </a:rPr>
               <a:t>• Typo « </a:t>
             </a:r>
             <a:r>
@@ -14221,42 +14200,6 @@
           </a:p>
         </p:txBody>
       </p:sp>
-      <p:pic>
-        <p:nvPicPr>
-          <p:cNvPr id="6" name="Image 5">
-            <a:extLst>
-              <a:ext uri="{FF2B5EF4-FFF2-40B4-BE49-F238E27FC236}">
-                <a16:creationId xmlns:a16="http://schemas.microsoft.com/office/drawing/2014/main" id="{BB320341-4000-17A1-243A-431EB257EAC8}"/>
-              </a:ext>
-            </a:extLst>
-          </p:cNvPr>
-          <p:cNvPicPr>
-            <a:picLocks noChangeAspect="1"/>
-          </p:cNvPicPr>
-          <p:nvPr/>
-        </p:nvPicPr>
-        <p:blipFill>
-          <a:blip r:embed="rId3">
-            <a:extLst>
-              <a:ext uri="{28A0092B-C50C-407E-A947-70E740481C1C}">
-                <a14:useLocalDpi xmlns:a14="http://schemas.microsoft.com/office/drawing/2010/main" val="0"/>
-              </a:ext>
-            </a:extLst>
-          </a:blip>
-          <a:stretch>
-            <a:fillRect/>
-          </a:stretch>
-        </p:blipFill>
-        <p:spPr>
-          <a:xfrm>
-            <a:off x="427845" y="1585451"/>
-            <a:ext cx="7450082" cy="2666438"/>
-          </a:xfrm>
-          <a:prstGeom prst="rect">
-            <a:avLst/>
-          </a:prstGeom>
-        </p:spPr>
-      </p:pic>
       <p:sp>
         <p:nvSpPr>
           <p:cNvPr id="9" name="ZoneTexte 8">
@@ -15153,6 +15096,42 @@
           </a:graphicData>
         </a:graphic>
       </p:graphicFrame>
+      <p:pic>
+        <p:nvPicPr>
+          <p:cNvPr id="7" name="Image 6">
+            <a:extLst>
+              <a:ext uri="{FF2B5EF4-FFF2-40B4-BE49-F238E27FC236}">
+                <a16:creationId xmlns:a16="http://schemas.microsoft.com/office/drawing/2014/main" id="{08C9C24A-E066-CE47-E105-BD99C7A04847}"/>
+              </a:ext>
+            </a:extLst>
+          </p:cNvPr>
+          <p:cNvPicPr>
+            <a:picLocks noChangeAspect="1"/>
+          </p:cNvPicPr>
+          <p:nvPr/>
+        </p:nvPicPr>
+        <p:blipFill>
+          <a:blip r:embed="rId3">
+            <a:extLst>
+              <a:ext uri="{28A0092B-C50C-407E-A947-70E740481C1C}">
+                <a14:useLocalDpi xmlns:a14="http://schemas.microsoft.com/office/drawing/2010/main" val="0"/>
+              </a:ext>
+            </a:extLst>
+          </a:blip>
+          <a:stretch>
+            <a:fillRect/>
+          </a:stretch>
+        </p:blipFill>
+        <p:spPr>
+          <a:xfrm>
+            <a:off x="538919" y="1486901"/>
+            <a:ext cx="8020050" cy="2276475"/>
+          </a:xfrm>
+          <a:prstGeom prst="rect">
+            <a:avLst/>
+          </a:prstGeom>
+        </p:spPr>
+      </p:pic>
     </p:spTree>
     <p:extLst>
       <p:ext uri="{BB962C8B-B14F-4D97-AF65-F5344CB8AC3E}">
@@ -17335,7 +17314,29 @@
                   </a:schemeClr>
                 </a:solidFill>
               </a:rPr>
-              <a:t>Ingère le XLSX Sportif, nettoie les NaN et typos</a:t>
+              <a:t>Ingère le XLSX Sportif, </a:t>
+            </a:r>
+            <a:r>
+              <a:rPr lang="fr-FR" noProof="0" dirty="0" err="1">
+                <a:solidFill>
+                  <a:schemeClr val="accent2">
+                    <a:lumMod val="40000"/>
+                    <a:lumOff val="60000"/>
+                  </a:schemeClr>
+                </a:solidFill>
+              </a:rPr>
+              <a:t>nettoi</a:t>
+            </a:r>
+            <a:r>
+              <a:rPr lang="fr-FR" noProof="0" dirty="0">
+                <a:solidFill>
+                  <a:schemeClr val="accent2">
+                    <a:lumMod val="40000"/>
+                    <a:lumOff val="60000"/>
+                  </a:schemeClr>
+                </a:solidFill>
+              </a:rPr>
+              <a:t> ,et typos</a:t>
             </a:r>
           </a:p>
         </p:txBody>
@@ -19861,7 +19862,7 @@
               <a:t> et déclenchement par </a:t>
             </a:r>
             <a:r>
-              <a:rPr lang="fr-FR" noProof="0" dirty="0" err="1">
+              <a:rPr lang="fr-FR" b="1" noProof="0" dirty="0" err="1">
                 <a:solidFill>
                   <a:schemeClr val="accent2">
                     <a:lumMod val="40000"/>

</xml_diff>

<commit_message>
P12 orchestration : secrets docker-compose via env vars, init.ps1 uv sync, uv.lock
</commit_message>
<xml_diff>
--- a/P12_Gerez_un_projet_d_infrastructure_aymeric_bailleul/_orchestration/_docs/ABAI_02_presentation.pptx
+++ b/P12_Gerez_un_projet_d_infrastructure_aymeric_bailleul/_orchestration/_docs/ABAI_02_presentation.pptx
@@ -209,7 +209,7 @@
           <a:p>
             <a:fld id="{F16B76E8-7572-4EB5-8BC1-D8F277DA4831}" type="datetimeFigureOut">
               <a:rPr lang="fr-FR" smtClean="0"/>
-              <a:t>25/03/2026</a:t>
+              <a:t>30/03/2026</a:t>
             </a:fld>
             <a:endParaRPr lang="fr-FR"/>
           </a:p>
@@ -520,25 +520,8 @@
           <a:bodyPr/>
           <a:lstStyle/>
           <a:p>
-            <a:pPr marL="0" marR="0" lvl="0" indent="0" algn="l" defTabSz="914400" rtl="0" eaLnBrk="1" fontAlgn="auto" latinLnBrk="0" hangingPunct="1">
-              <a:lnSpc>
-                <a:spcPct val="100000"/>
-              </a:lnSpc>
-              <a:spcBef>
-                <a:spcPts val="0"/>
-              </a:spcBef>
-              <a:spcAft>
-                <a:spcPts val="0"/>
-              </a:spcAft>
-              <a:buClrTx/>
-              <a:buSzTx/>
-              <a:buFontTx/>
-              <a:buNone/>
-              <a:tabLst/>
-              <a:defRPr/>
-            </a:pPr>
-            <a:r>
-              <a:rPr lang="fr-FR" sz="1200" b="0" i="0" kern="1200" dirty="0">
+            <a:r>
+              <a:rPr lang="fr-FR" sz="1200" b="1" i="0" kern="1200" dirty="0">
                 <a:solidFill>
                   <a:schemeClr val="tx1"/>
                 </a:solidFill>
@@ -547,27 +530,8 @@
                 <a:ea typeface="+mn-ea"/>
                 <a:cs typeface="+mn-cs"/>
               </a:rPr>
-              <a:t>🟠 Orange 	&gt; Sources 	           &gt; Données d'entrée (XLSX, API)</a:t>
-            </a:r>
-          </a:p>
-          <a:p>
-            <a:pPr marL="0" marR="0" lvl="0" indent="0" algn="l" defTabSz="914400" rtl="0" eaLnBrk="1" fontAlgn="auto" latinLnBrk="0" hangingPunct="1">
-              <a:lnSpc>
-                <a:spcPct val="100000"/>
-              </a:lnSpc>
-              <a:spcBef>
-                <a:spcPts val="0"/>
-              </a:spcBef>
-              <a:spcAft>
-                <a:spcPts val="0"/>
-              </a:spcAft>
-              <a:buClrTx/>
-              <a:buSzTx/>
-              <a:buFontTx/>
-              <a:buNone/>
-              <a:tabLst/>
-              <a:defRPr/>
-            </a:pPr>
+              <a:t>Prime sportive (5 % salaire brut)</a:t>
+            </a:r>
             <a:r>
               <a:rPr lang="fr-FR" sz="1200" b="0" i="0" kern="1200" dirty="0">
                 <a:solidFill>
@@ -578,29 +542,10 @@
                 <a:ea typeface="+mn-ea"/>
                 <a:cs typeface="+mn-cs"/>
               </a:rPr>
-              <a:t>🔵 Bleu foncé	&gt; ETL, PostgreSQL      &gt; Traitement et stockage</a:t>
-            </a:r>
-          </a:p>
-          <a:p>
-            <a:pPr marL="0" marR="0" lvl="0" indent="0" algn="l" defTabSz="914400" rtl="0" eaLnBrk="1" fontAlgn="auto" latinLnBrk="0" hangingPunct="1">
-              <a:lnSpc>
-                <a:spcPct val="100000"/>
-              </a:lnSpc>
-              <a:spcBef>
-                <a:spcPts val="0"/>
-              </a:spcBef>
-              <a:spcAft>
-                <a:spcPts val="0"/>
-              </a:spcAft>
-              <a:buClrTx/>
-              <a:buSzTx/>
-              <a:buFontTx/>
-              <a:buNone/>
-              <a:tabLst/>
-              <a:defRPr/>
-            </a:pPr>
-            <a:r>
-              <a:rPr lang="fr-FR" sz="1200" b="0" i="0" kern="1200" dirty="0">
+              <a:t> : venir au bureau à pied/vélo/trottinette ET habiter à moins de 15 km (marche/running) ou 25 km (vélo/trottinette). Distance calculée par Google </a:t>
+            </a:r>
+            <a:r>
+              <a:rPr lang="fr-FR" sz="1200" b="0" i="0" kern="1200" dirty="0" err="1">
                 <a:solidFill>
                   <a:schemeClr val="tx1"/>
                 </a:solidFill>
@@ -609,10 +554,10 @@
                 <a:ea typeface="+mn-ea"/>
                 <a:cs typeface="+mn-cs"/>
               </a:rPr>
-              <a:t>🔵 Bleu 	&gt; </a:t>
-            </a:r>
-            <a:r>
-              <a:rPr lang="fr-FR" sz="1200" b="0" i="0" kern="1200" dirty="0" err="1">
+              <a:t>Maps</a:t>
+            </a:r>
+            <a:r>
+              <a:rPr lang="fr-FR" sz="1200" b="0" i="0" kern="1200" dirty="0">
                 <a:solidFill>
                   <a:schemeClr val="tx1"/>
                 </a:solidFill>
@@ -621,10 +566,12 @@
                 <a:ea typeface="+mn-ea"/>
                 <a:cs typeface="+mn-cs"/>
               </a:rPr>
-              <a:t>Kestra</a:t>
-            </a:r>
-            <a:r>
-              <a:rPr lang="fr-FR" sz="1200" b="0" i="0" kern="1200" dirty="0">
+              <a:t>.</a:t>
+            </a:r>
+          </a:p>
+          <a:p>
+            <a:r>
+              <a:rPr lang="fr-FR" sz="1200" b="1" i="0" kern="1200" dirty="0">
                 <a:solidFill>
                   <a:schemeClr val="tx1"/>
                 </a:solidFill>
@@ -633,27 +580,8 @@
                 <a:ea typeface="+mn-ea"/>
                 <a:cs typeface="+mn-cs"/>
               </a:rPr>
-              <a:t> 	           &gt; Orchestration (le "chef d'orchestre")</a:t>
-            </a:r>
-          </a:p>
-          <a:p>
-            <a:pPr marL="0" marR="0" lvl="0" indent="0" algn="l" defTabSz="914400" rtl="0" eaLnBrk="1" fontAlgn="auto" latinLnBrk="0" hangingPunct="1">
-              <a:lnSpc>
-                <a:spcPct val="100000"/>
-              </a:lnSpc>
-              <a:spcBef>
-                <a:spcPts val="0"/>
-              </a:spcBef>
-              <a:spcAft>
-                <a:spcPts val="0"/>
-              </a:spcAft>
-              <a:buClrTx/>
-              <a:buSzTx/>
-              <a:buFontTx/>
-              <a:buNone/>
-              <a:tabLst/>
-              <a:defRPr/>
-            </a:pPr>
+              <a:t>5 jours bien-être</a:t>
+            </a:r>
             <a:r>
               <a:rPr lang="fr-FR" sz="1200" b="0" i="0" kern="1200" dirty="0">
                 <a:solidFill>
@@ -664,7 +592,7 @@
                 <a:ea typeface="+mn-ea"/>
                 <a:cs typeface="+mn-cs"/>
               </a:rPr>
-              <a:t>🟢 Vert 	&gt; </a:t>
+              <a:t> : avoir fait au moins 15 activités </a:t>
             </a:r>
             <a:r>
               <a:rPr lang="fr-FR" sz="1200" b="0" i="0" kern="1200" dirty="0" err="1">
@@ -676,7 +604,7 @@
                 <a:ea typeface="+mn-ea"/>
                 <a:cs typeface="+mn-cs"/>
               </a:rPr>
-              <a:t>dbt</a:t>
+              <a:t>Strava</a:t>
             </a:r>
             <a:r>
               <a:rPr lang="fr-FR" sz="1200" b="0" i="0" kern="1200" dirty="0">
@@ -688,27 +616,21 @@
                 <a:ea typeface="+mn-ea"/>
                 <a:cs typeface="+mn-cs"/>
               </a:rPr>
-              <a:t>, Power BI          &gt; Valorisation des données (transformations + restitution)</a:t>
-            </a:r>
-          </a:p>
-          <a:p>
-            <a:pPr marL="0" marR="0" lvl="0" indent="0" algn="l" defTabSz="914400" rtl="0" eaLnBrk="1" fontAlgn="auto" latinLnBrk="0" hangingPunct="1">
-              <a:lnSpc>
-                <a:spcPct val="100000"/>
-              </a:lnSpc>
-              <a:spcBef>
-                <a:spcPts val="0"/>
-              </a:spcBef>
-              <a:spcAft>
-                <a:spcPts val="0"/>
-              </a:spcAft>
-              <a:buClrTx/>
-              <a:buSzTx/>
-              <a:buFontTx/>
-              <a:buNone/>
-              <a:tabLst/>
-              <a:defRPr/>
-            </a:pPr>
+              <a:t> dans l'année, peu importe le sport.</a:t>
+            </a:r>
+          </a:p>
+          <a:p>
+            <a:endParaRPr lang="fr-FR" sz="1200" b="0" i="0" kern="1200" dirty="0">
+              <a:solidFill>
+                <a:schemeClr val="tx1"/>
+              </a:solidFill>
+              <a:effectLst/>
+              <a:latin typeface="+mn-lt"/>
+              <a:ea typeface="+mn-ea"/>
+              <a:cs typeface="+mn-cs"/>
+            </a:endParaRPr>
+          </a:p>
+          <a:p>
             <a:r>
               <a:rPr lang="fr-FR" sz="1200" b="0" i="0" kern="1200" dirty="0">
                 <a:solidFill>
@@ -719,66 +641,11 @@
                 <a:ea typeface="+mn-ea"/>
                 <a:cs typeface="+mn-cs"/>
               </a:rPr>
-              <a:t>🟣 Violet 	&gt; Slack 	           &gt; Communication / notifications</a:t>
-            </a:r>
-          </a:p>
-          <a:p>
-            <a:pPr marL="0" marR="0" lvl="0" indent="0" algn="l" defTabSz="914400" rtl="0" eaLnBrk="1" fontAlgn="auto" latinLnBrk="0" hangingPunct="1">
-              <a:lnSpc>
-                <a:spcPct val="100000"/>
-              </a:lnSpc>
-              <a:spcBef>
-                <a:spcPts val="0"/>
-              </a:spcBef>
-              <a:spcAft>
-                <a:spcPts val="0"/>
-              </a:spcAft>
-              <a:buClrTx/>
-              <a:buSzTx/>
-              <a:buFontTx/>
-              <a:buNone/>
-              <a:tabLst/>
-              <a:defRPr/>
-            </a:pPr>
-            <a:r>
-              <a:rPr lang="fr-FR" sz="1200" b="0" i="0" kern="1200" dirty="0">
-                <a:solidFill>
-                  <a:schemeClr val="tx1"/>
-                </a:solidFill>
-                <a:effectLst/>
-                <a:latin typeface="+mn-lt"/>
-                <a:ea typeface="+mn-ea"/>
-                <a:cs typeface="+mn-cs"/>
-              </a:rPr>
-              <a:t>🔴 Rouge 	&gt; </a:t>
-            </a:r>
-            <a:r>
-              <a:rPr lang="fr-FR" sz="1200" b="0" i="0" kern="1200" dirty="0" err="1">
-                <a:solidFill>
-                  <a:schemeClr val="tx1"/>
-                </a:solidFill>
-                <a:effectLst/>
-                <a:latin typeface="+mn-lt"/>
-                <a:ea typeface="+mn-ea"/>
-                <a:cs typeface="+mn-cs"/>
-              </a:rPr>
-              <a:t>Error</a:t>
-            </a:r>
-            <a:r>
-              <a:rPr lang="fr-FR" sz="1200" b="0" i="0" kern="1200" dirty="0">
-                <a:solidFill>
-                  <a:schemeClr val="tx1"/>
-                </a:solidFill>
-                <a:effectLst/>
-                <a:latin typeface="+mn-lt"/>
-                <a:ea typeface="+mn-ea"/>
-                <a:cs typeface="+mn-cs"/>
-              </a:rPr>
-              <a:t> Handler          &gt; Gestion des erreurs</a:t>
-            </a:r>
-          </a:p>
-          <a:p>
-            <a:endParaRPr lang="fr-FR" dirty="0"/>
+              <a:t>Les salariés inactifs (démissions, etc.) sont exclus des deux calculs.</a:t>
+            </a:r>
+          </a:p>
+          <a:p>
+            <a:endParaRPr lang="en-US" dirty="0"/>
           </a:p>
         </p:txBody>
       </p:sp>
@@ -799,7 +666,7 @@
           <a:p>
             <a:fld id="{99C5AD06-CE33-4E6E-97A2-90C845482EC4}" type="slidenum">
               <a:rPr lang="fr-FR" smtClean="0"/>
-              <a:t>4</a:t>
+              <a:t>2</a:t>
             </a:fld>
             <a:endParaRPr lang="fr-FR"/>
           </a:p>
@@ -808,7 +675,7 @@
     </p:spTree>
     <p:extLst>
       <p:ext uri="{BB962C8B-B14F-4D97-AF65-F5344CB8AC3E}">
-        <p14:creationId xmlns:p14="http://schemas.microsoft.com/office/powerpoint/2010/main" val="31356481"/>
+        <p14:creationId xmlns:p14="http://schemas.microsoft.com/office/powerpoint/2010/main" val="456461880"/>
       </p:ext>
     </p:extLst>
   </p:cSld>
@@ -819,6 +686,114 @@
 </file>
 
 <file path=ppt/notesSlides/notesSlide10.xml><?xml version="1.0" encoding="utf-8"?>
+<p:notes xmlns:a="http://schemas.openxmlformats.org/drawingml/2006/main" xmlns:r="http://schemas.openxmlformats.org/officeDocument/2006/relationships" xmlns:p="http://schemas.openxmlformats.org/presentationml/2006/main">
+  <p:cSld>
+    <p:spTree>
+      <p:nvGrpSpPr>
+        <p:cNvPr id="1" name="">
+          <a:extLst>
+            <a:ext uri="{FF2B5EF4-FFF2-40B4-BE49-F238E27FC236}">
+              <a16:creationId xmlns:a16="http://schemas.microsoft.com/office/drawing/2014/main" id="{E90BD923-6122-2994-304C-69ECEE1204EB}"/>
+            </a:ext>
+          </a:extLst>
+        </p:cNvPr>
+        <p:cNvGrpSpPr/>
+        <p:nvPr/>
+      </p:nvGrpSpPr>
+      <p:grpSpPr>
+        <a:xfrm>
+          <a:off x="0" y="0"/>
+          <a:ext cx="0" cy="0"/>
+          <a:chOff x="0" y="0"/>
+          <a:chExt cx="0" cy="0"/>
+        </a:xfrm>
+      </p:grpSpPr>
+      <p:sp>
+        <p:nvSpPr>
+          <p:cNvPr id="2" name="Espace réservé de l'image des diapositives 1">
+            <a:extLst>
+              <a:ext uri="{FF2B5EF4-FFF2-40B4-BE49-F238E27FC236}">
+                <a16:creationId xmlns:a16="http://schemas.microsoft.com/office/drawing/2014/main" id="{D2648A9C-EE24-0816-5364-5F8DE3194A05}"/>
+              </a:ext>
+            </a:extLst>
+          </p:cNvPr>
+          <p:cNvSpPr>
+            <a:spLocks noGrp="1" noRot="1" noChangeAspect="1"/>
+          </p:cNvSpPr>
+          <p:nvPr>
+            <p:ph type="sldImg"/>
+          </p:nvPr>
+        </p:nvSpPr>
+        <p:spPr/>
+      </p:sp>
+      <p:sp>
+        <p:nvSpPr>
+          <p:cNvPr id="3" name="Espace réservé des notes 2">
+            <a:extLst>
+              <a:ext uri="{FF2B5EF4-FFF2-40B4-BE49-F238E27FC236}">
+                <a16:creationId xmlns:a16="http://schemas.microsoft.com/office/drawing/2014/main" id="{EA3361B9-F082-D177-2ACA-25C1C011FAAF}"/>
+              </a:ext>
+            </a:extLst>
+          </p:cNvPr>
+          <p:cNvSpPr>
+            <a:spLocks noGrp="1"/>
+          </p:cNvSpPr>
+          <p:nvPr>
+            <p:ph type="body" idx="1"/>
+          </p:nvPr>
+        </p:nvSpPr>
+        <p:spPr/>
+        <p:txBody>
+          <a:bodyPr/>
+          <a:lstStyle/>
+          <a:p>
+            <a:endParaRPr lang="fr-FR" dirty="0"/>
+          </a:p>
+        </p:txBody>
+      </p:sp>
+      <p:sp>
+        <p:nvSpPr>
+          <p:cNvPr id="4" name="Espace réservé du numéro de diapositive 3">
+            <a:extLst>
+              <a:ext uri="{FF2B5EF4-FFF2-40B4-BE49-F238E27FC236}">
+                <a16:creationId xmlns:a16="http://schemas.microsoft.com/office/drawing/2014/main" id="{BBDB3B88-6C84-B9FE-6F00-31A5537C9D08}"/>
+              </a:ext>
+            </a:extLst>
+          </p:cNvPr>
+          <p:cNvSpPr>
+            <a:spLocks noGrp="1"/>
+          </p:cNvSpPr>
+          <p:nvPr>
+            <p:ph type="sldNum" sz="quarter" idx="5"/>
+          </p:nvPr>
+        </p:nvSpPr>
+        <p:spPr/>
+        <p:txBody>
+          <a:bodyPr/>
+          <a:lstStyle/>
+          <a:p>
+            <a:fld id="{99C5AD06-CE33-4E6E-97A2-90C845482EC4}" type="slidenum">
+              <a:rPr lang="fr-FR" smtClean="0"/>
+              <a:t>12</a:t>
+            </a:fld>
+            <a:endParaRPr lang="fr-FR"/>
+          </a:p>
+        </p:txBody>
+      </p:sp>
+    </p:spTree>
+    <p:extLst>
+      <p:ext uri="{BB962C8B-B14F-4D97-AF65-F5344CB8AC3E}">
+        <p14:creationId xmlns:p14="http://schemas.microsoft.com/office/powerpoint/2010/main" val="2679833592"/>
+      </p:ext>
+    </p:extLst>
+  </p:cSld>
+  <p:clrMapOvr>
+    <a:masterClrMapping/>
+  </p:clrMapOvr>
+</p:notes>
+</file>
+
+<file path=ppt/notesSlides/notesSlide11.xml><?xml version="1.0" encoding="utf-8"?>
 <p:notes xmlns:a="http://schemas.openxmlformats.org/drawingml/2006/main" xmlns:r="http://schemas.openxmlformats.org/officeDocument/2006/relationships" xmlns:p="http://schemas.openxmlformats.org/presentationml/2006/main">
   <p:cSld>
     <p:spTree>
@@ -946,136 +921,23 @@
           <a:bodyPr/>
           <a:lstStyle/>
           <a:p>
-            <a:pPr algn="l">
+            <a:pPr marL="0" marR="0" lvl="0" indent="0" algn="l" defTabSz="914400" rtl="0" eaLnBrk="1" fontAlgn="auto" latinLnBrk="0" hangingPunct="1">
+              <a:lnSpc>
+                <a:spcPct val="100000"/>
+              </a:lnSpc>
+              <a:spcBef>
+                <a:spcPts val="0"/>
+              </a:spcBef>
               <a:spcAft>
-                <a:spcPts val="600"/>
+                <a:spcPts val="0"/>
               </a:spcAft>
-              <a:defRPr sz="1400" b="1">
-                <a:solidFill>
-                  <a:srgbClr val="2C3E50"/>
-                </a:solidFill>
-                <a:latin typeface="Calibri"/>
-              </a:defRPr>
+              <a:buClrTx/>
+              <a:buSzTx/>
+              <a:buFontTx/>
+              <a:buNone/>
+              <a:tabLst/>
+              <a:defRPr/>
             </a:pPr>
-            <a:r>
-              <a:rPr lang="fr-FR" dirty="0"/>
-              <a:t>10 tables + 1 vue — Architecture </a:t>
-            </a:r>
-            <a:r>
-              <a:rPr lang="fr-FR" dirty="0" err="1"/>
-              <a:t>Medallion</a:t>
-            </a:r>
-            <a:r>
-              <a:rPr lang="fr-FR" dirty="0"/>
-              <a:t> adaptée au RGPD</a:t>
-            </a:r>
-          </a:p>
-          <a:p>
-            <a:pPr algn="l">
-              <a:spcAft>
-                <a:spcPts val="600"/>
-              </a:spcAft>
-              <a:defRPr sz="1200" b="0">
-                <a:solidFill>
-                  <a:srgbClr val="85929E"/>
-                </a:solidFill>
-                <a:latin typeface="Calibri"/>
-              </a:defRPr>
-            </a:pPr>
-            <a:r>
-              <a:rPr lang="fr-FR" dirty="0"/>
-              <a:t>• XLSX = couche </a:t>
-            </a:r>
-            <a:r>
-              <a:rPr lang="fr-FR" dirty="0" err="1"/>
-              <a:t>raw</a:t>
-            </a:r>
-            <a:r>
-              <a:rPr lang="fr-FR" dirty="0"/>
-              <a:t> logique (sur disque, jamais copiés en base) — seules les données </a:t>
-            </a:r>
-            <a:r>
-              <a:rPr lang="fr-FR" dirty="0" err="1"/>
-              <a:t>Strava</a:t>
-            </a:r>
-            <a:r>
-              <a:rPr lang="fr-FR" dirty="0"/>
-              <a:t> passent par </a:t>
-            </a:r>
-            <a:r>
-              <a:rPr lang="fr-FR" dirty="0" err="1"/>
-              <a:t>raw</a:t>
-            </a:r>
-            <a:r>
-              <a:rPr lang="fr-FR" dirty="0"/>
-              <a:t> en base</a:t>
-            </a:r>
-          </a:p>
-          <a:p>
-            <a:pPr algn="l">
-              <a:spcAft>
-                <a:spcPts val="600"/>
-              </a:spcAft>
-              <a:defRPr sz="1200" b="0">
-                <a:solidFill>
-                  <a:srgbClr val="85929E"/>
-                </a:solidFill>
-                <a:latin typeface="Calibri"/>
-              </a:defRPr>
-            </a:pPr>
-            <a:r>
-              <a:rPr lang="fr-FR" dirty="0"/>
-              <a:t>• </a:t>
-            </a:r>
-            <a:r>
-              <a:rPr lang="fr-FR" dirty="0" err="1"/>
-              <a:t>staging</a:t>
-            </a:r>
-            <a:r>
-              <a:rPr lang="fr-FR" dirty="0"/>
-              <a:t> = 1er niveau DB : anonymisé, nettoyé, incrémental (UPSERT + soft-</a:t>
-            </a:r>
-            <a:r>
-              <a:rPr lang="fr-FR" dirty="0" err="1"/>
-              <a:t>delete</a:t>
-            </a:r>
-            <a:r>
-              <a:rPr lang="fr-FR" dirty="0"/>
-              <a:t>)</a:t>
-            </a:r>
-          </a:p>
-          <a:p>
-            <a:pPr algn="l">
-              <a:spcAft>
-                <a:spcPts val="600"/>
-              </a:spcAft>
-              <a:defRPr sz="1200" b="0">
-                <a:solidFill>
-                  <a:srgbClr val="85929E"/>
-                </a:solidFill>
-                <a:latin typeface="Calibri"/>
-              </a:defRPr>
-            </a:pPr>
-            <a:r>
-              <a:rPr lang="fr-FR" dirty="0"/>
-              <a:t>• gold = métriques métier calculées par </a:t>
-            </a:r>
-            <a:r>
-              <a:rPr lang="fr-FR" dirty="0" err="1"/>
-              <a:t>dbt</a:t>
-            </a:r>
-            <a:r>
-              <a:rPr lang="fr-FR" dirty="0"/>
-              <a:t> (éligibilités, impact financier)</a:t>
-            </a:r>
-          </a:p>
-          <a:p>
-            <a:endParaRPr lang="fr-FR" dirty="0"/>
-          </a:p>
-          <a:p>
-            <a:endParaRPr lang="fr-FR" dirty="0"/>
-          </a:p>
-          <a:p>
             <a:r>
               <a:rPr lang="fr-FR" sz="1200" b="0" i="0" kern="1200" dirty="0">
                 <a:solidFill>
@@ -1086,12 +948,29 @@
                 <a:ea typeface="+mn-ea"/>
                 <a:cs typeface="+mn-cs"/>
               </a:rPr>
-              <a:t>Architecture de données en 3 couches progressives, inspirée des médailles olympiques :</a:t>
-            </a:r>
-          </a:p>
-          <a:p>
-            <a:r>
-              <a:rPr lang="fr-FR" sz="1200" b="1" i="0" kern="1200" dirty="0">
+              <a:t>🟠 Orange 	&gt; Sources 	           &gt; Données d'entrée (XLSX, API)</a:t>
+            </a:r>
+          </a:p>
+          <a:p>
+            <a:pPr marL="0" marR="0" lvl="0" indent="0" algn="l" defTabSz="914400" rtl="0" eaLnBrk="1" fontAlgn="auto" latinLnBrk="0" hangingPunct="1">
+              <a:lnSpc>
+                <a:spcPct val="100000"/>
+              </a:lnSpc>
+              <a:spcBef>
+                <a:spcPts val="0"/>
+              </a:spcBef>
+              <a:spcAft>
+                <a:spcPts val="0"/>
+              </a:spcAft>
+              <a:buClrTx/>
+              <a:buSzTx/>
+              <a:buFontTx/>
+              <a:buNone/>
+              <a:tabLst/>
+              <a:defRPr/>
+            </a:pPr>
+            <a:r>
+              <a:rPr lang="fr-FR" sz="1200" b="0" i="0" kern="1200" dirty="0">
                 <a:solidFill>
                   <a:schemeClr val="tx1"/>
                 </a:solidFill>
@@ -1100,10 +979,29 @@
                 <a:ea typeface="+mn-ea"/>
                 <a:cs typeface="+mn-cs"/>
               </a:rPr>
-              <a:t>Bronze (</a:t>
-            </a:r>
-            <a:r>
-              <a:rPr lang="fr-FR" sz="1200" b="1" i="0" kern="1200" dirty="0" err="1">
+              <a:t>🔵 Bleu foncé	&gt; ETL, PostgreSQL      &gt; Traitement et stockage</a:t>
+            </a:r>
+          </a:p>
+          <a:p>
+            <a:pPr marL="0" marR="0" lvl="0" indent="0" algn="l" defTabSz="914400" rtl="0" eaLnBrk="1" fontAlgn="auto" latinLnBrk="0" hangingPunct="1">
+              <a:lnSpc>
+                <a:spcPct val="100000"/>
+              </a:lnSpc>
+              <a:spcBef>
+                <a:spcPts val="0"/>
+              </a:spcBef>
+              <a:spcAft>
+                <a:spcPts val="0"/>
+              </a:spcAft>
+              <a:buClrTx/>
+              <a:buSzTx/>
+              <a:buFontTx/>
+              <a:buNone/>
+              <a:tabLst/>
+              <a:defRPr/>
+            </a:pPr>
+            <a:r>
+              <a:rPr lang="fr-FR" sz="1200" b="0" i="0" kern="1200" dirty="0">
                 <a:solidFill>
                   <a:schemeClr val="tx1"/>
                 </a:solidFill>
@@ -1112,10 +1010,10 @@
                 <a:ea typeface="+mn-ea"/>
                 <a:cs typeface="+mn-cs"/>
               </a:rPr>
-              <a:t>raw</a:t>
-            </a:r>
-            <a:r>
-              <a:rPr lang="fr-FR" sz="1200" b="1" i="0" kern="1200" dirty="0">
+              <a:t>🔵 Bleu 	&gt; </a:t>
+            </a:r>
+            <a:r>
+              <a:rPr lang="fr-FR" sz="1200" b="0" i="0" kern="1200" dirty="0" err="1">
                 <a:solidFill>
                   <a:schemeClr val="tx1"/>
                 </a:solidFill>
@@ -1124,7 +1022,7 @@
                 <a:ea typeface="+mn-ea"/>
                 <a:cs typeface="+mn-cs"/>
               </a:rPr>
-              <a:t>)</a:t>
+              <a:t>Kestra</a:t>
             </a:r>
             <a:r>
               <a:rPr lang="fr-FR" sz="1200" b="0" i="0" kern="1200" dirty="0">
@@ -1136,12 +1034,29 @@
                 <a:ea typeface="+mn-ea"/>
                 <a:cs typeface="+mn-cs"/>
               </a:rPr>
-              <a:t> : données brutes, ingérées telles quelles depuis les sources</a:t>
-            </a:r>
-          </a:p>
-          <a:p>
-            <a:r>
-              <a:rPr lang="fr-FR" sz="1200" b="1" i="0" kern="1200" dirty="0">
+              <a:t> 	           &gt; Orchestration (le "chef d'orchestre")</a:t>
+            </a:r>
+          </a:p>
+          <a:p>
+            <a:pPr marL="0" marR="0" lvl="0" indent="0" algn="l" defTabSz="914400" rtl="0" eaLnBrk="1" fontAlgn="auto" latinLnBrk="0" hangingPunct="1">
+              <a:lnSpc>
+                <a:spcPct val="100000"/>
+              </a:lnSpc>
+              <a:spcBef>
+                <a:spcPts val="0"/>
+              </a:spcBef>
+              <a:spcAft>
+                <a:spcPts val="0"/>
+              </a:spcAft>
+              <a:buClrTx/>
+              <a:buSzTx/>
+              <a:buFontTx/>
+              <a:buNone/>
+              <a:tabLst/>
+              <a:defRPr/>
+            </a:pPr>
+            <a:r>
+              <a:rPr lang="fr-FR" sz="1200" b="0" i="0" kern="1200" dirty="0">
                 <a:solidFill>
                   <a:schemeClr val="tx1"/>
                 </a:solidFill>
@@ -1150,10 +1065,10 @@
                 <a:ea typeface="+mn-ea"/>
                 <a:cs typeface="+mn-cs"/>
               </a:rPr>
-              <a:t>Silver (</a:t>
-            </a:r>
-            <a:r>
-              <a:rPr lang="fr-FR" sz="1200" b="1" i="0" kern="1200" dirty="0" err="1">
+              <a:t>🟢 Vert 	&gt; </a:t>
+            </a:r>
+            <a:r>
+              <a:rPr lang="fr-FR" sz="1200" b="0" i="0" kern="1200" dirty="0" err="1">
                 <a:solidFill>
                   <a:schemeClr val="tx1"/>
                 </a:solidFill>
@@ -1162,10 +1077,10 @@
                 <a:ea typeface="+mn-ea"/>
                 <a:cs typeface="+mn-cs"/>
               </a:rPr>
-              <a:t>staging</a:t>
-            </a:r>
-            <a:r>
-              <a:rPr lang="fr-FR" sz="1200" b="1" i="0" kern="1200" dirty="0">
+              <a:t>dbt</a:t>
+            </a:r>
+            <a:r>
+              <a:rPr lang="fr-FR" sz="1200" b="0" i="0" kern="1200" dirty="0">
                 <a:solidFill>
                   <a:schemeClr val="tx1"/>
                 </a:solidFill>
@@ -1174,8 +1089,27 @@
                 <a:ea typeface="+mn-ea"/>
                 <a:cs typeface="+mn-cs"/>
               </a:rPr>
-              <a:t>)</a:t>
-            </a:r>
+              <a:t>, Power BI          &gt; Valorisation des données (transformations + restitution)</a:t>
+            </a:r>
+          </a:p>
+          <a:p>
+            <a:pPr marL="0" marR="0" lvl="0" indent="0" algn="l" defTabSz="914400" rtl="0" eaLnBrk="1" fontAlgn="auto" latinLnBrk="0" hangingPunct="1">
+              <a:lnSpc>
+                <a:spcPct val="100000"/>
+              </a:lnSpc>
+              <a:spcBef>
+                <a:spcPts val="0"/>
+              </a:spcBef>
+              <a:spcAft>
+                <a:spcPts val="0"/>
+              </a:spcAft>
+              <a:buClrTx/>
+              <a:buSzTx/>
+              <a:buFontTx/>
+              <a:buNone/>
+              <a:tabLst/>
+              <a:defRPr/>
+            </a:pPr>
             <a:r>
               <a:rPr lang="fr-FR" sz="1200" b="0" i="0" kern="1200" dirty="0">
                 <a:solidFill>
@@ -1186,12 +1120,29 @@
                 <a:ea typeface="+mn-ea"/>
                 <a:cs typeface="+mn-cs"/>
               </a:rPr>
-              <a:t> : données nettoyées, dédupliquées, anonymisées, conformes</a:t>
-            </a:r>
-          </a:p>
-          <a:p>
-            <a:r>
-              <a:rPr lang="fr-FR" sz="1200" b="1" i="0" kern="1200" dirty="0">
+              <a:t>🟣 Violet 	&gt; Slack 	           &gt; Communication / notifications</a:t>
+            </a:r>
+          </a:p>
+          <a:p>
+            <a:pPr marL="0" marR="0" lvl="0" indent="0" algn="l" defTabSz="914400" rtl="0" eaLnBrk="1" fontAlgn="auto" latinLnBrk="0" hangingPunct="1">
+              <a:lnSpc>
+                <a:spcPct val="100000"/>
+              </a:lnSpc>
+              <a:spcBef>
+                <a:spcPts val="0"/>
+              </a:spcBef>
+              <a:spcAft>
+                <a:spcPts val="0"/>
+              </a:spcAft>
+              <a:buClrTx/>
+              <a:buSzTx/>
+              <a:buFontTx/>
+              <a:buNone/>
+              <a:tabLst/>
+              <a:defRPr/>
+            </a:pPr>
+            <a:r>
+              <a:rPr lang="fr-FR" sz="1200" b="0" i="0" kern="1200" dirty="0">
                 <a:solidFill>
                   <a:schemeClr val="tx1"/>
                 </a:solidFill>
@@ -1200,10 +1151,10 @@
                 <a:ea typeface="+mn-ea"/>
                 <a:cs typeface="+mn-cs"/>
               </a:rPr>
-              <a:t>Gold</a:t>
-            </a:r>
-            <a:r>
-              <a:rPr lang="fr-FR" sz="1200" b="0" i="0" kern="1200" dirty="0">
+              <a:t>🔴 Rouge 	&gt; </a:t>
+            </a:r>
+            <a:r>
+              <a:rPr lang="fr-FR" sz="1200" b="0" i="0" kern="1200" dirty="0" err="1">
                 <a:solidFill>
                   <a:schemeClr val="tx1"/>
                 </a:solidFill>
@@ -1212,10 +1163,10 @@
                 <a:ea typeface="+mn-ea"/>
                 <a:cs typeface="+mn-cs"/>
               </a:rPr>
-              <a:t> : données agrégées et enrichies, prêtes à être consommées par les outils métier (</a:t>
-            </a:r>
-            <a:r>
-              <a:rPr lang="fr-FR" sz="1200" b="0" i="0" kern="1200" dirty="0" err="1">
+              <a:t>Error</a:t>
+            </a:r>
+            <a:r>
+              <a:rPr lang="fr-FR" sz="1200" b="0" i="0" kern="1200" dirty="0">
                 <a:solidFill>
                   <a:schemeClr val="tx1"/>
                 </a:solidFill>
@@ -1224,33 +1175,7 @@
                 <a:ea typeface="+mn-ea"/>
                 <a:cs typeface="+mn-cs"/>
               </a:rPr>
-              <a:t>dashboards</a:t>
-            </a:r>
-            <a:r>
-              <a:rPr lang="fr-FR" sz="1200" b="0" i="0" kern="1200" dirty="0">
-                <a:solidFill>
-                  <a:schemeClr val="tx1"/>
-                </a:solidFill>
-                <a:effectLst/>
-                <a:latin typeface="+mn-lt"/>
-                <a:ea typeface="+mn-ea"/>
-                <a:cs typeface="+mn-cs"/>
-              </a:rPr>
-              <a:t>, rapports)</a:t>
-            </a:r>
-          </a:p>
-          <a:p>
-            <a:r>
-              <a:rPr lang="fr-FR" sz="1200" b="0" i="0" kern="1200" dirty="0">
-                <a:solidFill>
-                  <a:schemeClr val="tx1"/>
-                </a:solidFill>
-                <a:effectLst/>
-                <a:latin typeface="+mn-lt"/>
-                <a:ea typeface="+mn-ea"/>
-                <a:cs typeface="+mn-cs"/>
-              </a:rPr>
-              <a:t>Chaque couche améliore la qualité et la fiabilité des données par rapport à la précédente.</a:t>
+              <a:t> Handler          &gt; Gestion des erreurs</a:t>
             </a:r>
           </a:p>
           <a:p>
@@ -1275,6 +1200,398 @@
           <a:p>
             <a:fld id="{99C5AD06-CE33-4E6E-97A2-90C845482EC4}" type="slidenum">
               <a:rPr lang="fr-FR" smtClean="0"/>
+              <a:t>4</a:t>
+            </a:fld>
+            <a:endParaRPr lang="fr-FR"/>
+          </a:p>
+        </p:txBody>
+      </p:sp>
+    </p:spTree>
+    <p:extLst>
+      <p:ext uri="{BB962C8B-B14F-4D97-AF65-F5344CB8AC3E}">
+        <p14:creationId xmlns:p14="http://schemas.microsoft.com/office/powerpoint/2010/main" val="31356481"/>
+      </p:ext>
+    </p:extLst>
+  </p:cSld>
+  <p:clrMapOvr>
+    <a:masterClrMapping/>
+  </p:clrMapOvr>
+</p:notes>
+</file>
+
+<file path=ppt/notesSlides/notesSlide3.xml><?xml version="1.0" encoding="utf-8"?>
+<p:notes xmlns:a="http://schemas.openxmlformats.org/drawingml/2006/main" xmlns:r="http://schemas.openxmlformats.org/officeDocument/2006/relationships" xmlns:p="http://schemas.openxmlformats.org/presentationml/2006/main">
+  <p:cSld>
+    <p:spTree>
+      <p:nvGrpSpPr>
+        <p:cNvPr id="1" name=""/>
+        <p:cNvGrpSpPr/>
+        <p:nvPr/>
+      </p:nvGrpSpPr>
+      <p:grpSpPr>
+        <a:xfrm>
+          <a:off x="0" y="0"/>
+          <a:ext cx="0" cy="0"/>
+          <a:chOff x="0" y="0"/>
+          <a:chExt cx="0" cy="0"/>
+        </a:xfrm>
+      </p:grpSpPr>
+      <p:sp>
+        <p:nvSpPr>
+          <p:cNvPr id="2" name="Espace réservé de l'image des diapositives 1"/>
+          <p:cNvSpPr>
+            <a:spLocks noGrp="1" noRot="1" noChangeAspect="1"/>
+          </p:cNvSpPr>
+          <p:nvPr>
+            <p:ph type="sldImg"/>
+          </p:nvPr>
+        </p:nvSpPr>
+        <p:spPr/>
+      </p:sp>
+      <p:sp>
+        <p:nvSpPr>
+          <p:cNvPr id="3" name="Espace réservé des notes 2"/>
+          <p:cNvSpPr>
+            <a:spLocks noGrp="1"/>
+          </p:cNvSpPr>
+          <p:nvPr>
+            <p:ph type="body" idx="1"/>
+          </p:nvPr>
+        </p:nvSpPr>
+        <p:spPr/>
+        <p:txBody>
+          <a:bodyPr/>
+          <a:lstStyle/>
+          <a:p>
+            <a:pPr algn="l">
+              <a:spcAft>
+                <a:spcPts val="600"/>
+              </a:spcAft>
+              <a:defRPr sz="1400" b="1">
+                <a:solidFill>
+                  <a:srgbClr val="2C3E50"/>
+                </a:solidFill>
+                <a:latin typeface="Calibri"/>
+              </a:defRPr>
+            </a:pPr>
+            <a:r>
+              <a:rPr lang="fr-FR" dirty="0"/>
+              <a:t>10 tables + 1 vue — Architecture </a:t>
+            </a:r>
+            <a:r>
+              <a:rPr lang="fr-FR" dirty="0" err="1"/>
+              <a:t>Medallion</a:t>
+            </a:r>
+            <a:r>
+              <a:rPr lang="fr-FR" dirty="0"/>
+              <a:t> adaptée au RGPD</a:t>
+            </a:r>
+          </a:p>
+          <a:p>
+            <a:pPr algn="l">
+              <a:spcAft>
+                <a:spcPts val="600"/>
+              </a:spcAft>
+              <a:defRPr sz="1200" b="0">
+                <a:solidFill>
+                  <a:srgbClr val="85929E"/>
+                </a:solidFill>
+                <a:latin typeface="Calibri"/>
+              </a:defRPr>
+            </a:pPr>
+            <a:r>
+              <a:rPr lang="fr-FR" dirty="0"/>
+              <a:t>• XLSX = couche </a:t>
+            </a:r>
+            <a:r>
+              <a:rPr lang="fr-FR" dirty="0" err="1"/>
+              <a:t>raw</a:t>
+            </a:r>
+            <a:r>
+              <a:rPr lang="fr-FR" dirty="0"/>
+              <a:t> logique (sur disque, jamais copiés en base) — seules les données </a:t>
+            </a:r>
+            <a:r>
+              <a:rPr lang="fr-FR" dirty="0" err="1"/>
+              <a:t>Strava</a:t>
+            </a:r>
+            <a:r>
+              <a:rPr lang="fr-FR" dirty="0"/>
+              <a:t> passent par </a:t>
+            </a:r>
+            <a:r>
+              <a:rPr lang="fr-FR" dirty="0" err="1"/>
+              <a:t>raw</a:t>
+            </a:r>
+            <a:r>
+              <a:rPr lang="fr-FR" dirty="0"/>
+              <a:t> en base</a:t>
+            </a:r>
+          </a:p>
+          <a:p>
+            <a:pPr algn="l">
+              <a:spcAft>
+                <a:spcPts val="600"/>
+              </a:spcAft>
+              <a:defRPr sz="1200" b="0">
+                <a:solidFill>
+                  <a:srgbClr val="85929E"/>
+                </a:solidFill>
+                <a:latin typeface="Calibri"/>
+              </a:defRPr>
+            </a:pPr>
+            <a:r>
+              <a:rPr lang="fr-FR" dirty="0"/>
+              <a:t>• </a:t>
+            </a:r>
+            <a:r>
+              <a:rPr lang="fr-FR" dirty="0" err="1"/>
+              <a:t>staging</a:t>
+            </a:r>
+            <a:r>
+              <a:rPr lang="fr-FR" dirty="0"/>
+              <a:t> = 1er niveau DB : anonymisé, nettoyé, incrémental (UPSERT + soft-</a:t>
+            </a:r>
+            <a:r>
+              <a:rPr lang="fr-FR" dirty="0" err="1"/>
+              <a:t>delete</a:t>
+            </a:r>
+            <a:r>
+              <a:rPr lang="fr-FR" dirty="0"/>
+              <a:t>)</a:t>
+            </a:r>
+          </a:p>
+          <a:p>
+            <a:pPr algn="l">
+              <a:spcAft>
+                <a:spcPts val="600"/>
+              </a:spcAft>
+              <a:defRPr sz="1200" b="0">
+                <a:solidFill>
+                  <a:srgbClr val="85929E"/>
+                </a:solidFill>
+                <a:latin typeface="Calibri"/>
+              </a:defRPr>
+            </a:pPr>
+            <a:r>
+              <a:rPr lang="fr-FR" dirty="0"/>
+              <a:t>• gold = métriques métier calculées par </a:t>
+            </a:r>
+            <a:r>
+              <a:rPr lang="fr-FR" dirty="0" err="1"/>
+              <a:t>dbt</a:t>
+            </a:r>
+            <a:r>
+              <a:rPr lang="fr-FR" dirty="0"/>
+              <a:t> (éligibilités, impact financier)</a:t>
+            </a:r>
+          </a:p>
+          <a:p>
+            <a:endParaRPr lang="fr-FR" dirty="0"/>
+          </a:p>
+          <a:p>
+            <a:endParaRPr lang="fr-FR" dirty="0"/>
+          </a:p>
+          <a:p>
+            <a:r>
+              <a:rPr lang="fr-FR" sz="1200" b="0" i="0" kern="1200" dirty="0">
+                <a:solidFill>
+                  <a:schemeClr val="tx1"/>
+                </a:solidFill>
+                <a:effectLst/>
+                <a:latin typeface="+mn-lt"/>
+                <a:ea typeface="+mn-ea"/>
+                <a:cs typeface="+mn-cs"/>
+              </a:rPr>
+              <a:t>Architecture de données en 3 couches progressives, inspirée des médailles olympiques :</a:t>
+            </a:r>
+          </a:p>
+          <a:p>
+            <a:r>
+              <a:rPr lang="fr-FR" sz="1200" b="1" i="0" kern="1200" dirty="0">
+                <a:solidFill>
+                  <a:schemeClr val="tx1"/>
+                </a:solidFill>
+                <a:effectLst/>
+                <a:latin typeface="+mn-lt"/>
+                <a:ea typeface="+mn-ea"/>
+                <a:cs typeface="+mn-cs"/>
+              </a:rPr>
+              <a:t>Bronze (</a:t>
+            </a:r>
+            <a:r>
+              <a:rPr lang="fr-FR" sz="1200" b="1" i="0" kern="1200" dirty="0" err="1">
+                <a:solidFill>
+                  <a:schemeClr val="tx1"/>
+                </a:solidFill>
+                <a:effectLst/>
+                <a:latin typeface="+mn-lt"/>
+                <a:ea typeface="+mn-ea"/>
+                <a:cs typeface="+mn-cs"/>
+              </a:rPr>
+              <a:t>raw</a:t>
+            </a:r>
+            <a:r>
+              <a:rPr lang="fr-FR" sz="1200" b="1" i="0" kern="1200" dirty="0">
+                <a:solidFill>
+                  <a:schemeClr val="tx1"/>
+                </a:solidFill>
+                <a:effectLst/>
+                <a:latin typeface="+mn-lt"/>
+                <a:ea typeface="+mn-ea"/>
+                <a:cs typeface="+mn-cs"/>
+              </a:rPr>
+              <a:t>)</a:t>
+            </a:r>
+            <a:r>
+              <a:rPr lang="fr-FR" sz="1200" b="0" i="0" kern="1200" dirty="0">
+                <a:solidFill>
+                  <a:schemeClr val="tx1"/>
+                </a:solidFill>
+                <a:effectLst/>
+                <a:latin typeface="+mn-lt"/>
+                <a:ea typeface="+mn-ea"/>
+                <a:cs typeface="+mn-cs"/>
+              </a:rPr>
+              <a:t> : données brutes, ingérées telles quelles depuis les sources</a:t>
+            </a:r>
+          </a:p>
+          <a:p>
+            <a:r>
+              <a:rPr lang="fr-FR" sz="1200" b="1" i="0" kern="1200" dirty="0">
+                <a:solidFill>
+                  <a:schemeClr val="tx1"/>
+                </a:solidFill>
+                <a:effectLst/>
+                <a:latin typeface="+mn-lt"/>
+                <a:ea typeface="+mn-ea"/>
+                <a:cs typeface="+mn-cs"/>
+              </a:rPr>
+              <a:t>Silver (</a:t>
+            </a:r>
+            <a:r>
+              <a:rPr lang="fr-FR" sz="1200" b="1" i="0" kern="1200" dirty="0" err="1">
+                <a:solidFill>
+                  <a:schemeClr val="tx1"/>
+                </a:solidFill>
+                <a:effectLst/>
+                <a:latin typeface="+mn-lt"/>
+                <a:ea typeface="+mn-ea"/>
+                <a:cs typeface="+mn-cs"/>
+              </a:rPr>
+              <a:t>staging</a:t>
+            </a:r>
+            <a:r>
+              <a:rPr lang="fr-FR" sz="1200" b="1" i="0" kern="1200" dirty="0">
+                <a:solidFill>
+                  <a:schemeClr val="tx1"/>
+                </a:solidFill>
+                <a:effectLst/>
+                <a:latin typeface="+mn-lt"/>
+                <a:ea typeface="+mn-ea"/>
+                <a:cs typeface="+mn-cs"/>
+              </a:rPr>
+              <a:t>)</a:t>
+            </a:r>
+            <a:r>
+              <a:rPr lang="fr-FR" sz="1200" b="0" i="0" kern="1200" dirty="0">
+                <a:solidFill>
+                  <a:schemeClr val="tx1"/>
+                </a:solidFill>
+                <a:effectLst/>
+                <a:latin typeface="+mn-lt"/>
+                <a:ea typeface="+mn-ea"/>
+                <a:cs typeface="+mn-cs"/>
+              </a:rPr>
+              <a:t> : données nettoyées, dédupliquées, anonymisées, conformes</a:t>
+            </a:r>
+          </a:p>
+          <a:p>
+            <a:r>
+              <a:rPr lang="fr-FR" sz="1200" b="1" i="0" kern="1200" dirty="0">
+                <a:solidFill>
+                  <a:schemeClr val="tx1"/>
+                </a:solidFill>
+                <a:effectLst/>
+                <a:latin typeface="+mn-lt"/>
+                <a:ea typeface="+mn-ea"/>
+                <a:cs typeface="+mn-cs"/>
+              </a:rPr>
+              <a:t>Gold</a:t>
+            </a:r>
+            <a:r>
+              <a:rPr lang="fr-FR" sz="1200" b="0" i="0" kern="1200" dirty="0">
+                <a:solidFill>
+                  <a:schemeClr val="tx1"/>
+                </a:solidFill>
+                <a:effectLst/>
+                <a:latin typeface="+mn-lt"/>
+                <a:ea typeface="+mn-ea"/>
+                <a:cs typeface="+mn-cs"/>
+              </a:rPr>
+              <a:t> : données agrégées et enrichies, prêtes à être consommées par les outils métier (</a:t>
+            </a:r>
+            <a:r>
+              <a:rPr lang="fr-FR" sz="1200" b="0" i="0" kern="1200" dirty="0" err="1">
+                <a:solidFill>
+                  <a:schemeClr val="tx1"/>
+                </a:solidFill>
+                <a:effectLst/>
+                <a:latin typeface="+mn-lt"/>
+                <a:ea typeface="+mn-ea"/>
+                <a:cs typeface="+mn-cs"/>
+              </a:rPr>
+              <a:t>dashboards</a:t>
+            </a:r>
+            <a:r>
+              <a:rPr lang="fr-FR" sz="1200" b="0" i="0" kern="1200" dirty="0">
+                <a:solidFill>
+                  <a:schemeClr val="tx1"/>
+                </a:solidFill>
+                <a:effectLst/>
+                <a:latin typeface="+mn-lt"/>
+                <a:ea typeface="+mn-ea"/>
+                <a:cs typeface="+mn-cs"/>
+              </a:rPr>
+              <a:t>, rapports)</a:t>
+            </a:r>
+          </a:p>
+          <a:p>
+            <a:r>
+              <a:rPr lang="fr-FR" sz="1200" b="0" i="0" kern="1200" dirty="0">
+                <a:solidFill>
+                  <a:schemeClr val="tx1"/>
+                </a:solidFill>
+                <a:effectLst/>
+                <a:latin typeface="+mn-lt"/>
+                <a:ea typeface="+mn-ea"/>
+                <a:cs typeface="+mn-cs"/>
+              </a:rPr>
+              <a:t>Chaque couche améliore la qualité et la fiabilité des données par rapport à la précédente.</a:t>
+            </a:r>
+          </a:p>
+          <a:p>
+            <a:endParaRPr lang="fr-FR" dirty="0"/>
+          </a:p>
+        </p:txBody>
+      </p:sp>
+      <p:sp>
+        <p:nvSpPr>
+          <p:cNvPr id="4" name="Espace réservé du numéro de diapositive 3"/>
+          <p:cNvSpPr>
+            <a:spLocks noGrp="1"/>
+          </p:cNvSpPr>
+          <p:nvPr>
+            <p:ph type="sldNum" sz="quarter" idx="5"/>
+          </p:nvPr>
+        </p:nvSpPr>
+        <p:spPr/>
+        <p:txBody>
+          <a:bodyPr/>
+          <a:lstStyle/>
+          <a:p>
+            <a:fld id="{99C5AD06-CE33-4E6E-97A2-90C845482EC4}" type="slidenum">
+              <a:rPr lang="fr-FR" smtClean="0"/>
               <a:t>5</a:t>
             </a:fld>
             <a:endParaRPr lang="fr-FR"/>
@@ -1294,7 +1611,7 @@
 </p:notes>
 </file>
 
-<file path=ppt/notesSlides/notesSlide3.xml><?xml version="1.0" encoding="utf-8"?>
+<file path=ppt/notesSlides/notesSlide4.xml><?xml version="1.0" encoding="utf-8"?>
 <p:notes xmlns:a="http://schemas.openxmlformats.org/drawingml/2006/main" xmlns:r="http://schemas.openxmlformats.org/officeDocument/2006/relationships" xmlns:p="http://schemas.openxmlformats.org/presentationml/2006/main">
   <p:cSld>
     <p:spTree>
@@ -1627,7 +1944,7 @@
 </p:notes>
 </file>
 
-<file path=ppt/notesSlides/notesSlide4.xml><?xml version="1.0" encoding="utf-8"?>
+<file path=ppt/notesSlides/notesSlide5.xml><?xml version="1.0" encoding="utf-8"?>
 <p:notes xmlns:a="http://schemas.openxmlformats.org/drawingml/2006/main" xmlns:r="http://schemas.openxmlformats.org/officeDocument/2006/relationships" xmlns:p="http://schemas.openxmlformats.org/presentationml/2006/main">
   <p:cSld>
     <p:spTree>
@@ -1871,7 +2188,7 @@
 </p:notes>
 </file>
 
-<file path=ppt/notesSlides/notesSlide5.xml><?xml version="1.0" encoding="utf-8"?>
+<file path=ppt/notesSlides/notesSlide6.xml><?xml version="1.0" encoding="utf-8"?>
 <p:notes xmlns:a="http://schemas.openxmlformats.org/drawingml/2006/main" xmlns:r="http://schemas.openxmlformats.org/officeDocument/2006/relationships" xmlns:p="http://schemas.openxmlformats.org/presentationml/2006/main">
   <p:cSld>
     <p:spTree>
@@ -1933,6 +2250,583 @@
           <a:bodyPr/>
           <a:lstStyle/>
           <a:p>
+            <a:r>
+              <a:rPr lang="fr-FR" sz="1200" b="0" i="0" kern="1200" dirty="0">
+                <a:solidFill>
+                  <a:schemeClr val="tx1"/>
+                </a:solidFill>
+                <a:effectLst/>
+                <a:latin typeface="+mn-lt"/>
+                <a:ea typeface="+mn-ea"/>
+                <a:cs typeface="+mn-cs"/>
+              </a:rPr>
+              <a:t>La vraie question serait plutôt </a:t>
+            </a:r>
+            <a:r>
+              <a:rPr lang="fr-FR" sz="1200" b="0" i="1" kern="1200" dirty="0">
+                <a:solidFill>
+                  <a:schemeClr val="tx1"/>
+                </a:solidFill>
+                <a:effectLst/>
+                <a:latin typeface="+mn-lt"/>
+                <a:ea typeface="+mn-ea"/>
+                <a:cs typeface="+mn-cs"/>
+              </a:rPr>
+              <a:t>pourquoi pas tout en Python</a:t>
+            </a:r>
+            <a:r>
+              <a:rPr lang="fr-FR" sz="1200" b="0" i="0" kern="1200" dirty="0">
+                <a:solidFill>
+                  <a:schemeClr val="tx1"/>
+                </a:solidFill>
+                <a:effectLst/>
+                <a:latin typeface="+mn-lt"/>
+                <a:ea typeface="+mn-ea"/>
+                <a:cs typeface="+mn-cs"/>
+              </a:rPr>
+              <a:t> : parce que les transformations SQL dans </a:t>
+            </a:r>
+            <a:r>
+              <a:rPr lang="fr-FR" sz="1200" b="0" i="0" kern="1200" dirty="0" err="1">
+                <a:solidFill>
+                  <a:schemeClr val="tx1"/>
+                </a:solidFill>
+                <a:effectLst/>
+                <a:latin typeface="+mn-lt"/>
+                <a:ea typeface="+mn-ea"/>
+                <a:cs typeface="+mn-cs"/>
+              </a:rPr>
+              <a:t>dbt</a:t>
+            </a:r>
+            <a:r>
+              <a:rPr lang="fr-FR" sz="1200" b="0" i="0" kern="1200" dirty="0">
+                <a:solidFill>
+                  <a:schemeClr val="tx1"/>
+                </a:solidFill>
+                <a:effectLst/>
+                <a:latin typeface="+mn-lt"/>
+                <a:ea typeface="+mn-ea"/>
+                <a:cs typeface="+mn-cs"/>
+              </a:rPr>
+              <a:t> sont plus lisibles, testables et maintenables que des </a:t>
+            </a:r>
+            <a:r>
+              <a:rPr lang="fr-FR" sz="1200" b="0" i="0" kern="1200" dirty="0" err="1">
+                <a:solidFill>
+                  <a:schemeClr val="tx1"/>
+                </a:solidFill>
+                <a:effectLst/>
+                <a:latin typeface="+mn-lt"/>
+                <a:ea typeface="+mn-ea"/>
+                <a:cs typeface="+mn-cs"/>
+              </a:rPr>
+              <a:t>DataFrames</a:t>
+            </a:r>
+            <a:r>
+              <a:rPr lang="fr-FR" sz="1200" b="0" i="0" kern="1200" dirty="0">
+                <a:solidFill>
+                  <a:schemeClr val="tx1"/>
+                </a:solidFill>
+                <a:effectLst/>
+                <a:latin typeface="+mn-lt"/>
+                <a:ea typeface="+mn-ea"/>
+                <a:cs typeface="+mn-cs"/>
+              </a:rPr>
+              <a:t> pandas pour de la logique métier complexe (croisements de tables, </a:t>
+            </a:r>
+            <a:r>
+              <a:rPr lang="fr-FR" sz="1200" b="0" i="0" kern="1200" dirty="0" err="1">
+                <a:solidFill>
+                  <a:schemeClr val="tx1"/>
+                </a:solidFill>
+                <a:effectLst/>
+                <a:latin typeface="+mn-lt"/>
+                <a:ea typeface="+mn-ea"/>
+                <a:cs typeface="+mn-cs"/>
+              </a:rPr>
+              <a:t>aggrégations</a:t>
+            </a:r>
+            <a:r>
+              <a:rPr lang="fr-FR" sz="1200" b="0" i="0" kern="1200" dirty="0">
+                <a:solidFill>
+                  <a:schemeClr val="tx1"/>
+                </a:solidFill>
+                <a:effectLst/>
+                <a:latin typeface="+mn-lt"/>
+                <a:ea typeface="+mn-ea"/>
+                <a:cs typeface="+mn-cs"/>
+              </a:rPr>
+              <a:t> par département)</a:t>
+            </a:r>
+          </a:p>
+          <a:p>
+            <a:endParaRPr lang="fr-FR" sz="1200" b="0" i="0" kern="1200" dirty="0">
+              <a:solidFill>
+                <a:schemeClr val="tx1"/>
+              </a:solidFill>
+              <a:effectLst/>
+              <a:latin typeface="+mn-lt"/>
+              <a:ea typeface="+mn-ea"/>
+              <a:cs typeface="+mn-cs"/>
+            </a:endParaRPr>
+          </a:p>
+          <a:p>
+            <a:r>
+              <a:rPr lang="fr-FR" sz="1200" b="1" i="0" kern="1200" dirty="0">
+                <a:solidFill>
+                  <a:schemeClr val="tx1"/>
+                </a:solidFill>
+                <a:effectLst/>
+                <a:latin typeface="+mn-lt"/>
+                <a:ea typeface="+mn-ea"/>
+                <a:cs typeface="+mn-cs"/>
+              </a:rPr>
+              <a:t>Tests intégrés</a:t>
+            </a:r>
+            <a:r>
+              <a:rPr lang="fr-FR" sz="1200" b="0" i="0" kern="1200" dirty="0">
+                <a:solidFill>
+                  <a:schemeClr val="tx1"/>
+                </a:solidFill>
+                <a:effectLst/>
+                <a:latin typeface="+mn-lt"/>
+                <a:ea typeface="+mn-ea"/>
+                <a:cs typeface="+mn-cs"/>
+              </a:rPr>
+              <a:t> — 37 tests SQL (</a:t>
+            </a:r>
+            <a:r>
+              <a:rPr lang="fr-FR" sz="1200" b="0" i="0" kern="1200" dirty="0" err="1">
+                <a:solidFill>
+                  <a:schemeClr val="tx1"/>
+                </a:solidFill>
+                <a:effectLst/>
+                <a:latin typeface="+mn-lt"/>
+                <a:ea typeface="+mn-ea"/>
+                <a:cs typeface="+mn-cs"/>
+              </a:rPr>
+              <a:t>not_null</a:t>
+            </a:r>
+            <a:r>
+              <a:rPr lang="fr-FR" sz="1200" b="0" i="0" kern="1200" dirty="0">
+                <a:solidFill>
+                  <a:schemeClr val="tx1"/>
+                </a:solidFill>
+                <a:effectLst/>
+                <a:latin typeface="+mn-lt"/>
+                <a:ea typeface="+mn-ea"/>
+                <a:cs typeface="+mn-cs"/>
+              </a:rPr>
+              <a:t>, unique, </a:t>
+            </a:r>
+            <a:r>
+              <a:rPr lang="fr-FR" sz="1200" b="0" i="0" kern="1200" dirty="0" err="1">
+                <a:solidFill>
+                  <a:schemeClr val="tx1"/>
+                </a:solidFill>
+                <a:effectLst/>
+                <a:latin typeface="+mn-lt"/>
+                <a:ea typeface="+mn-ea"/>
+                <a:cs typeface="+mn-cs"/>
+              </a:rPr>
+              <a:t>accepted_values</a:t>
+            </a:r>
+            <a:r>
+              <a:rPr lang="fr-FR" sz="1200" b="0" i="0" kern="1200" dirty="0">
+                <a:solidFill>
+                  <a:schemeClr val="tx1"/>
+                </a:solidFill>
+                <a:effectLst/>
+                <a:latin typeface="+mn-lt"/>
+                <a:ea typeface="+mn-ea"/>
+                <a:cs typeface="+mn-cs"/>
+              </a:rPr>
+              <a:t>) sans écrire de code de test supplémentaire</a:t>
+            </a:r>
+          </a:p>
+          <a:p>
+            <a:r>
+              <a:rPr lang="fr-FR" sz="1200" b="1" i="0" kern="1200" dirty="0">
+                <a:solidFill>
+                  <a:schemeClr val="tx1"/>
+                </a:solidFill>
+                <a:effectLst/>
+                <a:latin typeface="+mn-lt"/>
+                <a:ea typeface="+mn-ea"/>
+                <a:cs typeface="+mn-cs"/>
+              </a:rPr>
+              <a:t>Documentation automatique</a:t>
+            </a:r>
+            <a:r>
+              <a:rPr lang="fr-FR" sz="1200" b="0" i="0" kern="1200" dirty="0">
+                <a:solidFill>
+                  <a:schemeClr val="tx1"/>
+                </a:solidFill>
+                <a:effectLst/>
+                <a:latin typeface="+mn-lt"/>
+                <a:ea typeface="+mn-ea"/>
+                <a:cs typeface="+mn-cs"/>
+              </a:rPr>
+              <a:t> — </a:t>
+            </a:r>
+            <a:r>
+              <a:rPr lang="fr-FR" sz="1200" b="0" i="0" kern="1200" dirty="0" err="1">
+                <a:solidFill>
+                  <a:schemeClr val="tx1"/>
+                </a:solidFill>
+                <a:effectLst/>
+                <a:latin typeface="+mn-lt"/>
+                <a:ea typeface="+mn-ea"/>
+                <a:cs typeface="+mn-cs"/>
+              </a:rPr>
+              <a:t>dbt</a:t>
+            </a:r>
+            <a:r>
+              <a:rPr lang="fr-FR" sz="1200" b="0" i="0" kern="1200" dirty="0">
+                <a:solidFill>
+                  <a:schemeClr val="tx1"/>
+                </a:solidFill>
+                <a:effectLst/>
+                <a:latin typeface="+mn-lt"/>
+                <a:ea typeface="+mn-ea"/>
+                <a:cs typeface="+mn-cs"/>
+              </a:rPr>
+              <a:t> docs </a:t>
+            </a:r>
+            <a:r>
+              <a:rPr lang="fr-FR" sz="1200" b="0" i="0" kern="1200" dirty="0" err="1">
+                <a:solidFill>
+                  <a:schemeClr val="tx1"/>
+                </a:solidFill>
+                <a:effectLst/>
+                <a:latin typeface="+mn-lt"/>
+                <a:ea typeface="+mn-ea"/>
+                <a:cs typeface="+mn-cs"/>
+              </a:rPr>
+              <a:t>generate</a:t>
+            </a:r>
+            <a:r>
+              <a:rPr lang="fr-FR" sz="1200" b="0" i="0" kern="1200" dirty="0">
+                <a:solidFill>
+                  <a:schemeClr val="tx1"/>
+                </a:solidFill>
+                <a:effectLst/>
+                <a:latin typeface="+mn-lt"/>
+                <a:ea typeface="+mn-ea"/>
+                <a:cs typeface="+mn-cs"/>
+              </a:rPr>
+              <a:t> produit le </a:t>
+            </a:r>
+            <a:r>
+              <a:rPr lang="fr-FR" sz="1200" b="0" i="0" kern="1200" dirty="0" err="1">
+                <a:solidFill>
+                  <a:schemeClr val="tx1"/>
+                </a:solidFill>
+                <a:effectLst/>
+                <a:latin typeface="+mn-lt"/>
+                <a:ea typeface="+mn-ea"/>
+                <a:cs typeface="+mn-cs"/>
+              </a:rPr>
+              <a:t>lineage</a:t>
+            </a:r>
+            <a:r>
+              <a:rPr lang="fr-FR" sz="1200" b="0" i="0" kern="1200" dirty="0">
+                <a:solidFill>
+                  <a:schemeClr val="tx1"/>
+                </a:solidFill>
+                <a:effectLst/>
+                <a:latin typeface="+mn-lt"/>
+                <a:ea typeface="+mn-ea"/>
+                <a:cs typeface="+mn-cs"/>
+              </a:rPr>
+              <a:t> graph et le </a:t>
+            </a:r>
+            <a:r>
+              <a:rPr lang="fr-FR" sz="1200" b="0" i="0" kern="1200" dirty="0" err="1">
+                <a:solidFill>
+                  <a:schemeClr val="tx1"/>
+                </a:solidFill>
+                <a:effectLst/>
+                <a:latin typeface="+mn-lt"/>
+                <a:ea typeface="+mn-ea"/>
+                <a:cs typeface="+mn-cs"/>
+              </a:rPr>
+              <a:t>catalog</a:t>
+            </a:r>
+            <a:r>
+              <a:rPr lang="fr-FR" sz="1200" b="0" i="0" kern="1200" dirty="0">
+                <a:solidFill>
+                  <a:schemeClr val="tx1"/>
+                </a:solidFill>
+                <a:effectLst/>
+                <a:latin typeface="+mn-lt"/>
+                <a:ea typeface="+mn-ea"/>
+                <a:cs typeface="+mn-cs"/>
+              </a:rPr>
+              <a:t> servis par </a:t>
+            </a:r>
+            <a:r>
+              <a:rPr lang="fr-FR" sz="1200" b="0" i="0" kern="1200" dirty="0" err="1">
+                <a:solidFill>
+                  <a:schemeClr val="tx1"/>
+                </a:solidFill>
+                <a:effectLst/>
+                <a:latin typeface="+mn-lt"/>
+                <a:ea typeface="+mn-ea"/>
+                <a:cs typeface="+mn-cs"/>
+              </a:rPr>
+              <a:t>nginx</a:t>
+            </a:r>
+            <a:r>
+              <a:rPr lang="fr-FR" sz="1200" b="0" i="0" kern="1200" dirty="0">
+                <a:solidFill>
+                  <a:schemeClr val="tx1"/>
+                </a:solidFill>
+                <a:effectLst/>
+                <a:latin typeface="+mn-lt"/>
+                <a:ea typeface="+mn-ea"/>
+                <a:cs typeface="+mn-cs"/>
+              </a:rPr>
+              <a:t> sur le port 4080</a:t>
+            </a:r>
+          </a:p>
+          <a:p>
+            <a:r>
+              <a:rPr lang="fr-FR" sz="1200" b="1" i="0" kern="1200" dirty="0">
+                <a:solidFill>
+                  <a:schemeClr val="tx1"/>
+                </a:solidFill>
+                <a:effectLst/>
+                <a:latin typeface="+mn-lt"/>
+                <a:ea typeface="+mn-ea"/>
+                <a:cs typeface="+mn-cs"/>
+              </a:rPr>
+              <a:t>Idempotence garantie</a:t>
+            </a:r>
+            <a:r>
+              <a:rPr lang="fr-FR" sz="1200" b="0" i="0" kern="1200" dirty="0">
+                <a:solidFill>
+                  <a:schemeClr val="tx1"/>
+                </a:solidFill>
+                <a:effectLst/>
+                <a:latin typeface="+mn-lt"/>
+                <a:ea typeface="+mn-ea"/>
+                <a:cs typeface="+mn-cs"/>
+              </a:rPr>
+              <a:t> — un </a:t>
+            </a:r>
+            <a:r>
+              <a:rPr lang="fr-FR" sz="1200" b="0" i="0" kern="1200" dirty="0" err="1">
+                <a:solidFill>
+                  <a:schemeClr val="tx1"/>
+                </a:solidFill>
+                <a:effectLst/>
+                <a:latin typeface="+mn-lt"/>
+                <a:ea typeface="+mn-ea"/>
+                <a:cs typeface="+mn-cs"/>
+              </a:rPr>
+              <a:t>dbt</a:t>
+            </a:r>
+            <a:r>
+              <a:rPr lang="fr-FR" sz="1200" b="0" i="0" kern="1200" dirty="0">
+                <a:solidFill>
+                  <a:schemeClr val="tx1"/>
+                </a:solidFill>
+                <a:effectLst/>
+                <a:latin typeface="+mn-lt"/>
+                <a:ea typeface="+mn-ea"/>
+                <a:cs typeface="+mn-cs"/>
+              </a:rPr>
+              <a:t> run peut être relancé N fois sans effet de bord (contrairement aux INSERT/TRUNCATE manuels)</a:t>
+            </a:r>
+          </a:p>
+          <a:p>
+            <a:r>
+              <a:rPr lang="fr-FR" sz="1200" b="1" i="0" kern="1200" dirty="0">
+                <a:solidFill>
+                  <a:schemeClr val="tx1"/>
+                </a:solidFill>
+                <a:effectLst/>
+                <a:latin typeface="+mn-lt"/>
+                <a:ea typeface="+mn-ea"/>
+                <a:cs typeface="+mn-cs"/>
+              </a:rPr>
+              <a:t>Séparation des responsabilités</a:t>
+            </a:r>
+            <a:r>
+              <a:rPr lang="fr-FR" sz="1200" b="0" i="0" kern="1200" dirty="0">
+                <a:solidFill>
+                  <a:schemeClr val="tx1"/>
+                </a:solidFill>
+                <a:effectLst/>
+                <a:latin typeface="+mn-lt"/>
+                <a:ea typeface="+mn-ea"/>
+                <a:cs typeface="+mn-cs"/>
+              </a:rPr>
+              <a:t> — Python gère l'ingestion et les appels API (Google </a:t>
+            </a:r>
+            <a:r>
+              <a:rPr lang="fr-FR" sz="1200" b="0" i="0" kern="1200" dirty="0" err="1">
+                <a:solidFill>
+                  <a:schemeClr val="tx1"/>
+                </a:solidFill>
+                <a:effectLst/>
+                <a:latin typeface="+mn-lt"/>
+                <a:ea typeface="+mn-ea"/>
+                <a:cs typeface="+mn-cs"/>
+              </a:rPr>
+              <a:t>Maps</a:t>
+            </a:r>
+            <a:r>
+              <a:rPr lang="fr-FR" sz="1200" b="0" i="0" kern="1200" dirty="0">
+                <a:solidFill>
+                  <a:schemeClr val="tx1"/>
+                </a:solidFill>
+                <a:effectLst/>
+                <a:latin typeface="+mn-lt"/>
+                <a:ea typeface="+mn-ea"/>
+                <a:cs typeface="+mn-cs"/>
+              </a:rPr>
+              <a:t>, </a:t>
+            </a:r>
+            <a:r>
+              <a:rPr lang="fr-FR" sz="1200" b="0" i="0" kern="1200" dirty="0" err="1">
+                <a:solidFill>
+                  <a:schemeClr val="tx1"/>
+                </a:solidFill>
+                <a:effectLst/>
+                <a:latin typeface="+mn-lt"/>
+                <a:ea typeface="+mn-ea"/>
+                <a:cs typeface="+mn-cs"/>
+              </a:rPr>
+              <a:t>Strava</a:t>
+            </a:r>
+            <a:r>
+              <a:rPr lang="fr-FR" sz="1200" b="0" i="0" kern="1200" dirty="0">
+                <a:solidFill>
+                  <a:schemeClr val="tx1"/>
+                </a:solidFill>
+                <a:effectLst/>
+                <a:latin typeface="+mn-lt"/>
+                <a:ea typeface="+mn-ea"/>
+                <a:cs typeface="+mn-cs"/>
+              </a:rPr>
+              <a:t>), </a:t>
+            </a:r>
+            <a:r>
+              <a:rPr lang="fr-FR" sz="1200" b="0" i="0" kern="1200" dirty="0" err="1">
+                <a:solidFill>
+                  <a:schemeClr val="tx1"/>
+                </a:solidFill>
+                <a:effectLst/>
+                <a:latin typeface="+mn-lt"/>
+                <a:ea typeface="+mn-ea"/>
+                <a:cs typeface="+mn-cs"/>
+              </a:rPr>
+              <a:t>dbt</a:t>
+            </a:r>
+            <a:r>
+              <a:rPr lang="fr-FR" sz="1200" b="0" i="0" kern="1200" dirty="0">
+                <a:solidFill>
+                  <a:schemeClr val="tx1"/>
+                </a:solidFill>
+                <a:effectLst/>
+                <a:latin typeface="+mn-lt"/>
+                <a:ea typeface="+mn-ea"/>
+                <a:cs typeface="+mn-cs"/>
+              </a:rPr>
+              <a:t> gère uniquement les transformations SQL pures (</a:t>
+            </a:r>
+            <a:r>
+              <a:rPr lang="fr-FR" sz="1200" b="0" i="0" kern="1200" dirty="0" err="1">
+                <a:solidFill>
+                  <a:schemeClr val="tx1"/>
+                </a:solidFill>
+                <a:effectLst/>
+                <a:latin typeface="+mn-lt"/>
+                <a:ea typeface="+mn-ea"/>
+                <a:cs typeface="+mn-cs"/>
+              </a:rPr>
+              <a:t>staging</a:t>
+            </a:r>
+            <a:r>
+              <a:rPr lang="fr-FR" sz="1200" b="0" i="0" kern="1200" dirty="0">
+                <a:solidFill>
+                  <a:schemeClr val="tx1"/>
+                </a:solidFill>
+                <a:effectLst/>
+                <a:latin typeface="+mn-lt"/>
+                <a:ea typeface="+mn-ea"/>
+                <a:cs typeface="+mn-cs"/>
+              </a:rPr>
+              <a:t> → gold), ce qui est la bonne séparation selon les bonnes pratiques ELT</a:t>
+            </a:r>
+          </a:p>
+          <a:p>
+            <a:r>
+              <a:rPr lang="fr-FR" sz="1200" b="1" i="0" kern="1200" dirty="0">
+                <a:solidFill>
+                  <a:schemeClr val="tx1"/>
+                </a:solidFill>
+                <a:effectLst/>
+                <a:latin typeface="+mn-lt"/>
+                <a:ea typeface="+mn-ea"/>
+                <a:cs typeface="+mn-cs"/>
+              </a:rPr>
+              <a:t>Versioning</a:t>
+            </a:r>
+            <a:r>
+              <a:rPr lang="fr-FR" sz="1200" b="0" i="0" kern="1200" dirty="0">
+                <a:solidFill>
+                  <a:schemeClr val="tx1"/>
+                </a:solidFill>
+                <a:effectLst/>
+                <a:latin typeface="+mn-lt"/>
+                <a:ea typeface="+mn-ea"/>
+                <a:cs typeface="+mn-cs"/>
+              </a:rPr>
+              <a:t> — les modèles SQL sont dans Git, l'historique des changements est traçable</a:t>
+            </a:r>
+          </a:p>
+          <a:p>
+            <a:r>
+              <a:rPr lang="fr-FR" sz="1200" b="0" i="0" kern="1200" dirty="0">
+                <a:solidFill>
+                  <a:schemeClr val="tx1"/>
+                </a:solidFill>
+                <a:effectLst/>
+                <a:latin typeface="+mn-lt"/>
+                <a:ea typeface="+mn-ea"/>
+                <a:cs typeface="+mn-cs"/>
+              </a:rPr>
+              <a:t>La vraie question serait plutôt </a:t>
+            </a:r>
+            <a:r>
+              <a:rPr lang="fr-FR" sz="1200" b="0" i="1" kern="1200" dirty="0">
+                <a:solidFill>
+                  <a:schemeClr val="tx1"/>
+                </a:solidFill>
+                <a:effectLst/>
+                <a:latin typeface="+mn-lt"/>
+                <a:ea typeface="+mn-ea"/>
+                <a:cs typeface="+mn-cs"/>
+              </a:rPr>
+              <a:t>pourquoi pas tout en Python</a:t>
+            </a:r>
+            <a:r>
+              <a:rPr lang="fr-FR" sz="1200" b="0" i="0" kern="1200" dirty="0">
+                <a:solidFill>
+                  <a:schemeClr val="tx1"/>
+                </a:solidFill>
+                <a:effectLst/>
+                <a:latin typeface="+mn-lt"/>
+                <a:ea typeface="+mn-ea"/>
+                <a:cs typeface="+mn-cs"/>
+              </a:rPr>
+              <a:t> : parce que les transformations SQL</a:t>
+            </a:r>
+          </a:p>
+          <a:p>
             <a:endParaRPr lang="fr-FR" dirty="0"/>
           </a:p>
         </p:txBody>
@@ -1979,7 +2873,7 @@
 </p:notes>
 </file>
 
-<file path=ppt/notesSlides/notesSlide6.xml><?xml version="1.0" encoding="utf-8"?>
+<file path=ppt/notesSlides/notesSlide7.xml><?xml version="1.0" encoding="utf-8"?>
 <p:notes xmlns:a="http://schemas.openxmlformats.org/drawingml/2006/main" xmlns:r="http://schemas.openxmlformats.org/officeDocument/2006/relationships" xmlns:p="http://schemas.openxmlformats.org/presentationml/2006/main">
   <p:cSld>
     <p:spTree>
@@ -3071,7 +3965,7 @@
 </p:notes>
 </file>
 
-<file path=ppt/notesSlides/notesSlide7.xml><?xml version="1.0" encoding="utf-8"?>
+<file path=ppt/notesSlides/notesSlide8.xml><?xml version="1.0" encoding="utf-8"?>
 <p:notes xmlns:a="http://schemas.openxmlformats.org/drawingml/2006/main" xmlns:r="http://schemas.openxmlformats.org/officeDocument/2006/relationships" xmlns:p="http://schemas.openxmlformats.org/presentationml/2006/main">
   <p:cSld>
     <p:spTree>
@@ -3251,7 +4145,7 @@
 </p:notes>
 </file>
 
-<file path=ppt/notesSlides/notesSlide8.xml><?xml version="1.0" encoding="utf-8"?>
+<file path=ppt/notesSlides/notesSlide9.xml><?xml version="1.0" encoding="utf-8"?>
 <p:notes xmlns:a="http://schemas.openxmlformats.org/drawingml/2006/main" xmlns:r="http://schemas.openxmlformats.org/officeDocument/2006/relationships" xmlns:p="http://schemas.openxmlformats.org/presentationml/2006/main">
   <p:cSld>
     <p:spTree>
@@ -3350,114 +4244,6 @@
     <p:extLst>
       <p:ext uri="{BB962C8B-B14F-4D97-AF65-F5344CB8AC3E}">
         <p14:creationId xmlns:p14="http://schemas.microsoft.com/office/powerpoint/2010/main" val="2238431240"/>
-      </p:ext>
-    </p:extLst>
-  </p:cSld>
-  <p:clrMapOvr>
-    <a:masterClrMapping/>
-  </p:clrMapOvr>
-</p:notes>
-</file>
-
-<file path=ppt/notesSlides/notesSlide9.xml><?xml version="1.0" encoding="utf-8"?>
-<p:notes xmlns:a="http://schemas.openxmlformats.org/drawingml/2006/main" xmlns:r="http://schemas.openxmlformats.org/officeDocument/2006/relationships" xmlns:p="http://schemas.openxmlformats.org/presentationml/2006/main">
-  <p:cSld>
-    <p:spTree>
-      <p:nvGrpSpPr>
-        <p:cNvPr id="1" name="">
-          <a:extLst>
-            <a:ext uri="{FF2B5EF4-FFF2-40B4-BE49-F238E27FC236}">
-              <a16:creationId xmlns:a16="http://schemas.microsoft.com/office/drawing/2014/main" id="{E90BD923-6122-2994-304C-69ECEE1204EB}"/>
-            </a:ext>
-          </a:extLst>
-        </p:cNvPr>
-        <p:cNvGrpSpPr/>
-        <p:nvPr/>
-      </p:nvGrpSpPr>
-      <p:grpSpPr>
-        <a:xfrm>
-          <a:off x="0" y="0"/>
-          <a:ext cx="0" cy="0"/>
-          <a:chOff x="0" y="0"/>
-          <a:chExt cx="0" cy="0"/>
-        </a:xfrm>
-      </p:grpSpPr>
-      <p:sp>
-        <p:nvSpPr>
-          <p:cNvPr id="2" name="Espace réservé de l'image des diapositives 1">
-            <a:extLst>
-              <a:ext uri="{FF2B5EF4-FFF2-40B4-BE49-F238E27FC236}">
-                <a16:creationId xmlns:a16="http://schemas.microsoft.com/office/drawing/2014/main" id="{D2648A9C-EE24-0816-5364-5F8DE3194A05}"/>
-              </a:ext>
-            </a:extLst>
-          </p:cNvPr>
-          <p:cNvSpPr>
-            <a:spLocks noGrp="1" noRot="1" noChangeAspect="1"/>
-          </p:cNvSpPr>
-          <p:nvPr>
-            <p:ph type="sldImg"/>
-          </p:nvPr>
-        </p:nvSpPr>
-        <p:spPr/>
-      </p:sp>
-      <p:sp>
-        <p:nvSpPr>
-          <p:cNvPr id="3" name="Espace réservé des notes 2">
-            <a:extLst>
-              <a:ext uri="{FF2B5EF4-FFF2-40B4-BE49-F238E27FC236}">
-                <a16:creationId xmlns:a16="http://schemas.microsoft.com/office/drawing/2014/main" id="{EA3361B9-F082-D177-2ACA-25C1C011FAAF}"/>
-              </a:ext>
-            </a:extLst>
-          </p:cNvPr>
-          <p:cNvSpPr>
-            <a:spLocks noGrp="1"/>
-          </p:cNvSpPr>
-          <p:nvPr>
-            <p:ph type="body" idx="1"/>
-          </p:nvPr>
-        </p:nvSpPr>
-        <p:spPr/>
-        <p:txBody>
-          <a:bodyPr/>
-          <a:lstStyle/>
-          <a:p>
-            <a:endParaRPr lang="fr-FR" dirty="0"/>
-          </a:p>
-        </p:txBody>
-      </p:sp>
-      <p:sp>
-        <p:nvSpPr>
-          <p:cNvPr id="4" name="Espace réservé du numéro de diapositive 3">
-            <a:extLst>
-              <a:ext uri="{FF2B5EF4-FFF2-40B4-BE49-F238E27FC236}">
-                <a16:creationId xmlns:a16="http://schemas.microsoft.com/office/drawing/2014/main" id="{BBDB3B88-6C84-B9FE-6F00-31A5537C9D08}"/>
-              </a:ext>
-            </a:extLst>
-          </p:cNvPr>
-          <p:cNvSpPr>
-            <a:spLocks noGrp="1"/>
-          </p:cNvSpPr>
-          <p:nvPr>
-            <p:ph type="sldNum" sz="quarter" idx="5"/>
-          </p:nvPr>
-        </p:nvSpPr>
-        <p:spPr/>
-        <p:txBody>
-          <a:bodyPr/>
-          <a:lstStyle/>
-          <a:p>
-            <a:fld id="{99C5AD06-CE33-4E6E-97A2-90C845482EC4}" type="slidenum">
-              <a:rPr lang="fr-FR" smtClean="0"/>
-              <a:t>12</a:t>
-            </a:fld>
-            <a:endParaRPr lang="fr-FR"/>
-          </a:p>
-        </p:txBody>
-      </p:sp>
-    </p:spTree>
-    <p:extLst>
-      <p:ext uri="{BB962C8B-B14F-4D97-AF65-F5344CB8AC3E}">
-        <p14:creationId xmlns:p14="http://schemas.microsoft.com/office/powerpoint/2010/main" val="2679833592"/>
       </p:ext>
     </p:extLst>
   </p:cSld>
@@ -3614,7 +4400,7 @@
           <a:p>
             <a:fld id="{C372C99E-D69C-4ADF-8C8D-41420D3DDB02}" type="datetimeFigureOut">
               <a:rPr lang="fr-FR" smtClean="0"/>
-              <a:t>25/03/2026</a:t>
+              <a:t>30/03/2026</a:t>
             </a:fld>
             <a:endParaRPr lang="fr-FR"/>
           </a:p>
@@ -3812,7 +4598,7 @@
           <a:p>
             <a:fld id="{C372C99E-D69C-4ADF-8C8D-41420D3DDB02}" type="datetimeFigureOut">
               <a:rPr lang="fr-FR" smtClean="0"/>
-              <a:t>25/03/2026</a:t>
+              <a:t>30/03/2026</a:t>
             </a:fld>
             <a:endParaRPr lang="fr-FR"/>
           </a:p>
@@ -4020,7 +4806,7 @@
           <a:p>
             <a:fld id="{C372C99E-D69C-4ADF-8C8D-41420D3DDB02}" type="datetimeFigureOut">
               <a:rPr lang="fr-FR" smtClean="0"/>
-              <a:t>25/03/2026</a:t>
+              <a:t>30/03/2026</a:t>
             </a:fld>
             <a:endParaRPr lang="fr-FR"/>
           </a:p>
@@ -4218,7 +5004,7 @@
           <a:p>
             <a:fld id="{C372C99E-D69C-4ADF-8C8D-41420D3DDB02}" type="datetimeFigureOut">
               <a:rPr lang="fr-FR" smtClean="0"/>
-              <a:t>25/03/2026</a:t>
+              <a:t>30/03/2026</a:t>
             </a:fld>
             <a:endParaRPr lang="fr-FR"/>
           </a:p>
@@ -4493,7 +5279,7 @@
           <a:p>
             <a:fld id="{C372C99E-D69C-4ADF-8C8D-41420D3DDB02}" type="datetimeFigureOut">
               <a:rPr lang="fr-FR" smtClean="0"/>
-              <a:t>25/03/2026</a:t>
+              <a:t>30/03/2026</a:t>
             </a:fld>
             <a:endParaRPr lang="fr-FR"/>
           </a:p>
@@ -4758,7 +5544,7 @@
           <a:p>
             <a:fld id="{C372C99E-D69C-4ADF-8C8D-41420D3DDB02}" type="datetimeFigureOut">
               <a:rPr lang="fr-FR" smtClean="0"/>
-              <a:t>25/03/2026</a:t>
+              <a:t>30/03/2026</a:t>
             </a:fld>
             <a:endParaRPr lang="fr-FR"/>
           </a:p>
@@ -5170,7 +5956,7 @@
           <a:p>
             <a:fld id="{C372C99E-D69C-4ADF-8C8D-41420D3DDB02}" type="datetimeFigureOut">
               <a:rPr lang="fr-FR" smtClean="0"/>
-              <a:t>25/03/2026</a:t>
+              <a:t>30/03/2026</a:t>
             </a:fld>
             <a:endParaRPr lang="fr-FR"/>
           </a:p>
@@ -5311,7 +6097,7 @@
           <a:p>
             <a:fld id="{C372C99E-D69C-4ADF-8C8D-41420D3DDB02}" type="datetimeFigureOut">
               <a:rPr lang="fr-FR" smtClean="0"/>
-              <a:t>25/03/2026</a:t>
+              <a:t>30/03/2026</a:t>
             </a:fld>
             <a:endParaRPr lang="fr-FR"/>
           </a:p>
@@ -5424,7 +6210,7 @@
           <a:p>
             <a:fld id="{C372C99E-D69C-4ADF-8C8D-41420D3DDB02}" type="datetimeFigureOut">
               <a:rPr lang="fr-FR" smtClean="0"/>
-              <a:t>25/03/2026</a:t>
+              <a:t>30/03/2026</a:t>
             </a:fld>
             <a:endParaRPr lang="fr-FR"/>
           </a:p>
@@ -5735,7 +6521,7 @@
           <a:p>
             <a:fld id="{C372C99E-D69C-4ADF-8C8D-41420D3DDB02}" type="datetimeFigureOut">
               <a:rPr lang="fr-FR" smtClean="0"/>
-              <a:t>25/03/2026</a:t>
+              <a:t>30/03/2026</a:t>
             </a:fld>
             <a:endParaRPr lang="fr-FR"/>
           </a:p>
@@ -6023,7 +6809,7 @@
           <a:p>
             <a:fld id="{C372C99E-D69C-4ADF-8C8D-41420D3DDB02}" type="datetimeFigureOut">
               <a:rPr lang="fr-FR" smtClean="0"/>
-              <a:t>25/03/2026</a:t>
+              <a:t>30/03/2026</a:t>
             </a:fld>
             <a:endParaRPr lang="fr-FR"/>
           </a:p>
@@ -6273,7 +7059,7 @@
           <a:p>
             <a:fld id="{C372C99E-D69C-4ADF-8C8D-41420D3DDB02}" type="datetimeFigureOut">
               <a:rPr lang="fr-FR" smtClean="0"/>
-              <a:t>25/03/2026</a:t>
+              <a:t>30/03/2026</a:t>
             </a:fld>
             <a:endParaRPr lang="fr-FR"/>
           </a:p>
@@ -12482,7 +13268,7 @@
           <p:nvPr/>
         </p:nvPicPr>
         <p:blipFill>
-          <a:blip r:embed="rId2">
+          <a:blip r:embed="rId3">
             <a:extLst>
               <a:ext uri="{28A0092B-C50C-407E-A947-70E740481C1C}">
                 <a14:useLocalDpi xmlns:a14="http://schemas.microsoft.com/office/drawing/2010/main" val="0"/>
@@ -16305,42 +17091,6 @@
           </a:graphicData>
         </a:graphic>
       </p:graphicFrame>
-      <p:pic>
-        <p:nvPicPr>
-          <p:cNvPr id="11" name="Image 10">
-            <a:extLst>
-              <a:ext uri="{FF2B5EF4-FFF2-40B4-BE49-F238E27FC236}">
-                <a16:creationId xmlns:a16="http://schemas.microsoft.com/office/drawing/2014/main" id="{04D58951-D82C-6A8A-DD76-63777C25FDC8}"/>
-              </a:ext>
-            </a:extLst>
-          </p:cNvPr>
-          <p:cNvPicPr>
-            <a:picLocks noChangeAspect="1"/>
-          </p:cNvPicPr>
-          <p:nvPr/>
-        </p:nvPicPr>
-        <p:blipFill>
-          <a:blip r:embed="rId3">
-            <a:extLst>
-              <a:ext uri="{28A0092B-C50C-407E-A947-70E740481C1C}">
-                <a14:useLocalDpi xmlns:a14="http://schemas.microsoft.com/office/drawing/2010/main" val="0"/>
-              </a:ext>
-            </a:extLst>
-          </a:blip>
-          <a:stretch>
-            <a:fillRect/>
-          </a:stretch>
-        </p:blipFill>
-        <p:spPr>
-          <a:xfrm>
-            <a:off x="2121909" y="2221007"/>
-            <a:ext cx="8010525" cy="2247900"/>
-          </a:xfrm>
-          <a:prstGeom prst="rect">
-            <a:avLst/>
-          </a:prstGeom>
-        </p:spPr>
-      </p:pic>
       <p:sp>
         <p:nvSpPr>
           <p:cNvPr id="14" name="ZoneTexte 13">
@@ -16383,6 +17133,42 @@
           </a:p>
         </p:txBody>
       </p:sp>
+      <p:pic>
+        <p:nvPicPr>
+          <p:cNvPr id="10" name="Image 9">
+            <a:extLst>
+              <a:ext uri="{FF2B5EF4-FFF2-40B4-BE49-F238E27FC236}">
+                <a16:creationId xmlns:a16="http://schemas.microsoft.com/office/drawing/2014/main" id="{32782960-9BC5-9229-EC02-BAB0F9CFCF36}"/>
+              </a:ext>
+            </a:extLst>
+          </p:cNvPr>
+          <p:cNvPicPr>
+            <a:picLocks noChangeAspect="1"/>
+          </p:cNvPicPr>
+          <p:nvPr/>
+        </p:nvPicPr>
+        <p:blipFill>
+          <a:blip r:embed="rId3">
+            <a:extLst>
+              <a:ext uri="{28A0092B-C50C-407E-A947-70E740481C1C}">
+                <a14:useLocalDpi xmlns:a14="http://schemas.microsoft.com/office/drawing/2010/main" val="0"/>
+              </a:ext>
+            </a:extLst>
+          </a:blip>
+          <a:stretch>
+            <a:fillRect/>
+          </a:stretch>
+        </p:blipFill>
+        <p:spPr>
+          <a:xfrm>
+            <a:off x="2090737" y="2305050"/>
+            <a:ext cx="8010525" cy="2247900"/>
+          </a:xfrm>
+          <a:prstGeom prst="rect">
+            <a:avLst/>
+          </a:prstGeom>
+        </p:spPr>
+      </p:pic>
     </p:spTree>
     <p:extLst>
       <p:ext uri="{BB962C8B-B14F-4D97-AF65-F5344CB8AC3E}">
@@ -17488,8 +18274,49 @@
                   </a:schemeClr>
                 </a:solidFill>
               </a:rPr>
-              <a:t>Crée les schémas, tables et rôles PostgreSQL</a:t>
-            </a:r>
+              <a:t>Nettoie et valide les données </a:t>
+            </a:r>
+            <a:r>
+              <a:rPr lang="fr-FR" noProof="0" dirty="0" err="1">
+                <a:solidFill>
+                  <a:schemeClr val="accent2">
+                    <a:lumMod val="40000"/>
+                    <a:lumOff val="60000"/>
+                  </a:schemeClr>
+                </a:solidFill>
+              </a:rPr>
+              <a:t>raw</a:t>
+            </a:r>
+            <a:r>
+              <a:rPr lang="fr-FR" noProof="0" dirty="0">
+                <a:solidFill>
+                  <a:schemeClr val="accent2">
+                    <a:lumMod val="40000"/>
+                    <a:lumOff val="60000"/>
+                  </a:schemeClr>
+                </a:solidFill>
+              </a:rPr>
+              <a:t> → </a:t>
+            </a:r>
+            <a:r>
+              <a:rPr lang="fr-FR" noProof="0" dirty="0" err="1">
+                <a:solidFill>
+                  <a:schemeClr val="accent2">
+                    <a:lumMod val="40000"/>
+                    <a:lumOff val="60000"/>
+                  </a:schemeClr>
+                </a:solidFill>
+              </a:rPr>
+              <a:t>staging</a:t>
+            </a:r>
+            <a:endParaRPr lang="fr-FR" noProof="0" dirty="0">
+              <a:solidFill>
+                <a:schemeClr val="accent2">
+                  <a:lumMod val="40000"/>
+                  <a:lumOff val="60000"/>
+                </a:schemeClr>
+              </a:solidFill>
+            </a:endParaRPr>
           </a:p>
         </p:txBody>
       </p:sp>

</xml_diff>